<commit_message>
feat(presentation): upgrade pitch deck with 3D popping transitions, ambient mesh, and KNIGHT.VAULT branding
</commit_message>
<xml_diff>
--- a/Midnight_Privacy_Payment_Vault_Presentation.pptx
+++ b/Midnight_Privacy_Payment_Vault_Presentation.pptx
@@ -3113,7 +3113,7 @@
             <a:avLst/>
           </a:prstGeom>
           <a:solidFill>
-            <a:srgbClr val="0B0D11"/>
+            <a:srgbClr val="08090D"/>
           </a:solidFill>
           <a:ln>
             <a:noFill/>
@@ -3169,13 +3169,13 @@
               </a:spcAft>
               <a:defRPr sz="1100" b="1">
                 <a:solidFill>
-                  <a:srgbClr val="10B981"/>
-                </a:solidFill>
-                <a:latin typeface="Arial"/>
-              </a:defRPr>
-            </a:pPr>
-            <a:r>
-              <a:t>MIDNIGHT NETWORK ZERO-KNOWLEDGE DAPP</a:t>
+                  <a:srgbClr val="00F5A0"/>
+                </a:solidFill>
+                <a:latin typeface="Arial"/>
+              </a:defRPr>
+            </a:pPr>
+            <a:r>
+              <a:t>MIDNIGHT NETWORK // ZERO-KNOWLEDGE SETTLEMENT PROTOCOL</a:t>
             </a:r>
           </a:p>
           <a:p>
@@ -3183,28 +3183,28 @@
               <a:spcAft>
                 <a:spcPts val="1200"/>
               </a:spcAft>
-              <a:defRPr sz="3600" b="1">
-                <a:solidFill>
-                  <a:srgbClr val="F8FAFC"/>
-                </a:solidFill>
-                <a:latin typeface="Arial"/>
-              </a:defRPr>
-            </a:pPr>
-            <a:r>
-              <a:t>Midnight Privacy Payment Vault</a:t>
-            </a:r>
-          </a:p>
-          <a:p>
-            <a:pPr>
-              <a:defRPr sz="1500">
-                <a:solidFill>
-                  <a:srgbClr val="94A3B8"/>
-                </a:solidFill>
-                <a:latin typeface="Arial"/>
-              </a:defRPr>
-            </a:pPr>
-            <a:r>
-              <a:t>Non-Custodial ZK Escrow, Compact Smart Contracts, ProofStation 0-Gas Balancing, and Institutional UI</a:t>
+              <a:defRPr sz="3800" b="1">
+                <a:solidFill>
+                  <a:srgbClr val="FFFFFF"/>
+                </a:solidFill>
+                <a:latin typeface="Arial"/>
+              </a:defRPr>
+            </a:pPr>
+            <a:r>
+              <a:t>KNIGHT.VAULT (v0.20)</a:t>
+            </a:r>
+          </a:p>
+          <a:p>
+            <a:pPr>
+              <a:defRPr sz="1400">
+                <a:solidFill>
+                  <a:srgbClr val="94A3B8"/>
+                </a:solidFill>
+                <a:latin typeface="Arial"/>
+              </a:defRPr>
+            </a:pPr>
+            <a:r>
+              <a:t>Institutional Zero-Knowledge Custody, Compact Smart Contracts, ProofStation 0-Gas Balancing, and Armored Privacy</a:t>
             </a:r>
           </a:p>
         </p:txBody>
@@ -3218,17 +3218,17 @@
         <p:spPr>
           <a:xfrm>
             <a:off x="914400" y="4480560"/>
-            <a:ext cx="10332720" cy="1371600"/>
+            <a:ext cx="10332720" cy="1463040"/>
           </a:xfrm>
           <a:prstGeom prst="roundRect">
             <a:avLst/>
           </a:prstGeom>
           <a:solidFill>
-            <a:srgbClr val="12151C"/>
+            <a:srgbClr val="0E1117"/>
           </a:solidFill>
           <a:ln w="12700">
             <a:solidFill>
-              <a:srgbClr val="1F242E"/>
+              <a:srgbClr val="232A38"/>
             </a:solidFill>
           </a:ln>
         </p:spPr>
@@ -3262,8 +3262,8 @@
         </p:nvSpPr>
         <p:spPr>
           <a:xfrm>
-            <a:off x="1188720" y="4663440"/>
-            <a:ext cx="9784080" cy="1005840"/>
+            <a:off x="1188720" y="4617720"/>
+            <a:ext cx="9784080" cy="1188720"/>
           </a:xfrm>
           <a:prstGeom prst="rect">
             <a:avLst/>
@@ -3279,13 +3279,13 @@
             <a:pPr>
               <a:defRPr sz="1200" b="1">
                 <a:solidFill>
-                  <a:srgbClr val="3B82F6"/>
-                </a:solidFill>
-                <a:latin typeface="Arial"/>
-              </a:defRPr>
-            </a:pPr>
-            <a:r>
-              <a:t>Core Innovation: Mathematical Zero-Knowledge Witness Auth + Zero User Gas Fees (1AM Sponsor Flow)</a:t>
+                  <a:srgbClr val="00F5A0"/>
+                </a:solidFill>
+                <a:latin typeface="Arial"/>
+              </a:defRPr>
+            </a:pPr>
+            <a:r>
+              <a:t>Core Innovation: Mathematical ZK Witness Auth + Sponsored Dust Transactions (Zero User Gas)</a:t>
             </a:r>
           </a:p>
           <a:p>
@@ -3293,15 +3293,28 @@
               <a:spcBef>
                 <a:spcPts val="600"/>
               </a:spcBef>
-              <a:defRPr sz="1050">
-                <a:solidFill>
-                  <a:srgbClr val="94A3B8"/>
-                </a:solidFill>
-                <a:latin typeface="Arial"/>
-              </a:defRPr>
-            </a:pPr>
-            <a:r>
-              <a:t>Stack: Compact v0.20+ | Docker Proof Server (6300) | Midnight.js SDK | React 18 | Vite | Tailwind (Impeccable 0-Flaw)</a:t>
+              <a:defRPr sz="1100" b="1">
+                <a:solidFill>
+                  <a:srgbClr val="818CF8"/>
+                </a:solidFill>
+                <a:latin typeface="Arial"/>
+              </a:defRPr>
+            </a:pPr>
+            <a:r>
+              <a:t>Architected &amp; Engineered by: Kshitij Adakane (Vibe Coder, Systems Builder &amp; Applied AI/ML)</a:t>
+            </a:r>
+          </a:p>
+          <a:p>
+            <a:pPr>
+              <a:defRPr sz="1000">
+                <a:solidFill>
+                  <a:srgbClr val="94A3B8"/>
+                </a:solidFill>
+                <a:latin typeface="Arial"/>
+              </a:defRPr>
+            </a:pPr>
+            <a:r>
+              <a:t>Stack: Compact v0.20+ | Docker ProofStation (:6300) | Midnight.js SDK | React 18 | Vite | Tailwind Kinetic UI</a:t>
             </a:r>
           </a:p>
         </p:txBody>
@@ -3339,7 +3352,7 @@
             <a:avLst/>
           </a:prstGeom>
           <a:solidFill>
-            <a:srgbClr val="0B0D11"/>
+            <a:srgbClr val="08090D"/>
           </a:solidFill>
           <a:ln>
             <a:noFill/>
@@ -3392,13 +3405,13 @@
             <a:pPr>
               <a:defRPr sz="950" b="1">
                 <a:solidFill>
-                  <a:srgbClr val="3B82F6"/>
-                </a:solidFill>
-                <a:latin typeface="Arial"/>
-              </a:defRPr>
-            </a:pPr>
-            <a:r>
-              <a:t>MIDNIGHT NETWORK • HACKATHON PITCH DECK</a:t>
+                  <a:srgbClr val="00F5A0"/>
+                </a:solidFill>
+                <a:latin typeface="Arial"/>
+              </a:defRPr>
+            </a:pPr>
+            <a:r>
+              <a:t>KNIGHT.VAULT // ZERO-KNOWLEDGE PROTOCOL DECK</a:t>
             </a:r>
           </a:p>
         </p:txBody>
@@ -3428,7 +3441,7 @@
             <a:pPr>
               <a:defRPr sz="2000" b="1">
                 <a:solidFill>
-                  <a:srgbClr val="F8FAFC"/>
+                  <a:srgbClr val="FFFFFF"/>
                 </a:solidFill>
                 <a:latin typeface="Arial"/>
               </a:defRPr>
@@ -3454,7 +3467,7 @@
             <a:avLst/>
           </a:prstGeom>
           <a:solidFill>
-            <a:srgbClr val="1F242E"/>
+            <a:srgbClr val="232A38"/>
           </a:solidFill>
           <a:ln>
             <a:noFill/>
@@ -3497,11 +3510,11 @@
             <a:avLst/>
           </a:prstGeom>
           <a:solidFill>
-            <a:srgbClr val="12151C"/>
+            <a:srgbClr val="0E1117"/>
           </a:solidFill>
           <a:ln w="12700">
             <a:solidFill>
-              <a:srgbClr val="1F242E"/>
+              <a:srgbClr val="232A38"/>
             </a:solidFill>
           </a:ln>
         </p:spPr>
@@ -3552,7 +3565,7 @@
             <a:pPr>
               <a:defRPr sz="1300" b="1">
                 <a:solidFill>
-                  <a:srgbClr val="10B981"/>
+                  <a:srgbClr val="00F5A0"/>
                 </a:solidFill>
                 <a:latin typeface="Arial"/>
               </a:defRPr>
@@ -3697,11 +3710,11 @@
             <a:avLst/>
           </a:prstGeom>
           <a:solidFill>
-            <a:srgbClr val="12151C"/>
+            <a:srgbClr val="0E1117"/>
           </a:solidFill>
           <a:ln w="12700">
             <a:solidFill>
-              <a:srgbClr val="1F242E"/>
+              <a:srgbClr val="232A38"/>
             </a:solidFill>
           </a:ln>
         </p:spPr>
@@ -3881,11 +3894,11 @@
             <a:avLst/>
           </a:prstGeom>
           <a:solidFill>
-            <a:srgbClr val="12151C"/>
+            <a:srgbClr val="0E1117"/>
           </a:solidFill>
           <a:ln w="12700">
             <a:solidFill>
-              <a:srgbClr val="1F242E"/>
+              <a:srgbClr val="232A38"/>
             </a:solidFill>
           </a:ln>
         </p:spPr>
@@ -4083,7 +4096,7 @@
             <a:avLst/>
           </a:prstGeom>
           <a:solidFill>
-            <a:srgbClr val="0B0D11"/>
+            <a:srgbClr val="08090D"/>
           </a:solidFill>
           <a:ln>
             <a:noFill/>
@@ -4136,13 +4149,13 @@
             <a:pPr>
               <a:defRPr sz="950" b="1">
                 <a:solidFill>
-                  <a:srgbClr val="3B82F6"/>
-                </a:solidFill>
-                <a:latin typeface="Arial"/>
-              </a:defRPr>
-            </a:pPr>
-            <a:r>
-              <a:t>MIDNIGHT NETWORK • HACKATHON PITCH DECK</a:t>
+                  <a:srgbClr val="00F5A0"/>
+                </a:solidFill>
+                <a:latin typeface="Arial"/>
+              </a:defRPr>
+            </a:pPr>
+            <a:r>
+              <a:t>KNIGHT.VAULT // ZERO-KNOWLEDGE PROTOCOL DECK</a:t>
             </a:r>
           </a:p>
         </p:txBody>
@@ -4172,7 +4185,7 @@
             <a:pPr>
               <a:defRPr sz="2000" b="1">
                 <a:solidFill>
-                  <a:srgbClr val="F8FAFC"/>
+                  <a:srgbClr val="FFFFFF"/>
                 </a:solidFill>
                 <a:latin typeface="Arial"/>
               </a:defRPr>
@@ -4198,7 +4211,7 @@
             <a:avLst/>
           </a:prstGeom>
           <a:solidFill>
-            <a:srgbClr val="1F242E"/>
+            <a:srgbClr val="232A38"/>
           </a:solidFill>
           <a:ln>
             <a:noFill/>
@@ -4241,11 +4254,11 @@
             <a:avLst/>
           </a:prstGeom>
           <a:solidFill>
-            <a:srgbClr val="161B26"/>
+            <a:srgbClr val="141923"/>
           </a:solidFill>
           <a:ln w="12700">
             <a:solidFill>
-              <a:srgbClr val="1F242E"/>
+              <a:srgbClr val="232A38"/>
             </a:solidFill>
           </a:ln>
         </p:spPr>
@@ -4296,7 +4309,7 @@
             <a:pPr>
               <a:defRPr sz="1300" b="1">
                 <a:solidFill>
-                  <a:srgbClr val="10B981"/>
+                  <a:srgbClr val="00F5A0"/>
                 </a:solidFill>
                 <a:latin typeface="Arial"/>
               </a:defRPr>
@@ -4443,7 +4456,7 @@
             <a:avLst/>
           </a:prstGeom>
           <a:solidFill>
-            <a:srgbClr val="0B0D11"/>
+            <a:srgbClr val="08090D"/>
           </a:solidFill>
           <a:ln>
             <a:noFill/>
@@ -4496,13 +4509,13 @@
             <a:pPr>
               <a:defRPr sz="950" b="1">
                 <a:solidFill>
-                  <a:srgbClr val="3B82F6"/>
-                </a:solidFill>
-                <a:latin typeface="Arial"/>
-              </a:defRPr>
-            </a:pPr>
-            <a:r>
-              <a:t>MIDNIGHT NETWORK • HACKATHON PITCH DECK</a:t>
+                  <a:srgbClr val="00F5A0"/>
+                </a:solidFill>
+                <a:latin typeface="Arial"/>
+              </a:defRPr>
+            </a:pPr>
+            <a:r>
+              <a:t>KNIGHT.VAULT // ZERO-KNOWLEDGE PROTOCOL DECK</a:t>
             </a:r>
           </a:p>
         </p:txBody>
@@ -4532,7 +4545,7 @@
             <a:pPr>
               <a:defRPr sz="2000" b="1">
                 <a:solidFill>
-                  <a:srgbClr val="F8FAFC"/>
+                  <a:srgbClr val="FFFFFF"/>
                 </a:solidFill>
                 <a:latin typeface="Arial"/>
               </a:defRPr>
@@ -4558,7 +4571,7 @@
             <a:avLst/>
           </a:prstGeom>
           <a:solidFill>
-            <a:srgbClr val="1F242E"/>
+            <a:srgbClr val="232A38"/>
           </a:solidFill>
           <a:ln>
             <a:noFill/>
@@ -4601,11 +4614,11 @@
             <a:avLst/>
           </a:prstGeom>
           <a:solidFill>
-            <a:srgbClr val="12151C"/>
+            <a:srgbClr val="0E1117"/>
           </a:solidFill>
           <a:ln w="12700">
             <a:solidFill>
-              <a:srgbClr val="1F242E"/>
+              <a:srgbClr val="232A38"/>
             </a:solidFill>
           </a:ln>
         </p:spPr>
@@ -4769,11 +4782,11 @@
             <a:avLst/>
           </a:prstGeom>
           <a:solidFill>
-            <a:srgbClr val="12151C"/>
+            <a:srgbClr val="0E1117"/>
           </a:solidFill>
           <a:ln w="12700">
             <a:solidFill>
-              <a:srgbClr val="1F242E"/>
+              <a:srgbClr val="232A38"/>
             </a:solidFill>
           </a:ln>
         </p:spPr>
@@ -4824,7 +4837,7 @@
             <a:pPr>
               <a:defRPr sz="1300" b="1">
                 <a:solidFill>
-                  <a:srgbClr val="10B981"/>
+                  <a:srgbClr val="00F5A0"/>
                 </a:solidFill>
                 <a:latin typeface="Arial"/>
               </a:defRPr>
@@ -4955,7 +4968,7 @@
             <a:avLst/>
           </a:prstGeom>
           <a:solidFill>
-            <a:srgbClr val="0B0D11"/>
+            <a:srgbClr val="08090D"/>
           </a:solidFill>
           <a:ln>
             <a:noFill/>
@@ -5008,13 +5021,13 @@
             <a:pPr>
               <a:defRPr sz="950" b="1">
                 <a:solidFill>
-                  <a:srgbClr val="3B82F6"/>
-                </a:solidFill>
-                <a:latin typeface="Arial"/>
-              </a:defRPr>
-            </a:pPr>
-            <a:r>
-              <a:t>MIDNIGHT NETWORK • HACKATHON PITCH DECK</a:t>
+                  <a:srgbClr val="00F5A0"/>
+                </a:solidFill>
+                <a:latin typeface="Arial"/>
+              </a:defRPr>
+            </a:pPr>
+            <a:r>
+              <a:t>KNIGHT.VAULT // ZERO-KNOWLEDGE PROTOCOL DECK</a:t>
             </a:r>
           </a:p>
         </p:txBody>
@@ -5044,7 +5057,7 @@
             <a:pPr>
               <a:defRPr sz="2000" b="1">
                 <a:solidFill>
-                  <a:srgbClr val="F8FAFC"/>
+                  <a:srgbClr val="FFFFFF"/>
                 </a:solidFill>
                 <a:latin typeface="Arial"/>
               </a:defRPr>
@@ -5070,7 +5083,7 @@
             <a:avLst/>
           </a:prstGeom>
           <a:solidFill>
-            <a:srgbClr val="1F242E"/>
+            <a:srgbClr val="232A38"/>
           </a:solidFill>
           <a:ln>
             <a:noFill/>
@@ -5113,11 +5126,11 @@
             <a:avLst/>
           </a:prstGeom>
           <a:solidFill>
-            <a:srgbClr val="12151C"/>
+            <a:srgbClr val="0E1117"/>
           </a:solidFill>
           <a:ln w="12700">
             <a:solidFill>
-              <a:srgbClr val="1F242E"/>
+              <a:srgbClr val="232A38"/>
             </a:solidFill>
           </a:ln>
         </p:spPr>
@@ -5168,7 +5181,7 @@
             <a:pPr>
               <a:defRPr sz="1300" b="1">
                 <a:solidFill>
-                  <a:srgbClr val="3B82F6"/>
+                  <a:srgbClr val="818CF8"/>
                 </a:solidFill>
                 <a:latin typeface="Arial"/>
               </a:defRPr>
@@ -5265,11 +5278,11 @@
             <a:avLst/>
           </a:prstGeom>
           <a:solidFill>
-            <a:srgbClr val="12151C"/>
+            <a:srgbClr val="0E1117"/>
           </a:solidFill>
           <a:ln w="12700">
             <a:solidFill>
-              <a:srgbClr val="1F242E"/>
+              <a:srgbClr val="232A38"/>
             </a:solidFill>
           </a:ln>
         </p:spPr>
@@ -5417,11 +5430,11 @@
             <a:avLst/>
           </a:prstGeom>
           <a:solidFill>
-            <a:srgbClr val="12151C"/>
+            <a:srgbClr val="0E1117"/>
           </a:solidFill>
           <a:ln w="12700">
             <a:solidFill>
-              <a:srgbClr val="1F242E"/>
+              <a:srgbClr val="232A38"/>
             </a:solidFill>
           </a:ln>
         </p:spPr>
@@ -5472,7 +5485,7 @@
             <a:pPr>
               <a:defRPr sz="1300" b="1">
                 <a:solidFill>
-                  <a:srgbClr val="10B981"/>
+                  <a:srgbClr val="00F5A0"/>
                 </a:solidFill>
                 <a:latin typeface="Arial"/>
               </a:defRPr>
@@ -5569,11 +5582,11 @@
             <a:avLst/>
           </a:prstGeom>
           <a:solidFill>
-            <a:srgbClr val="12151C"/>
+            <a:srgbClr val="0E1117"/>
           </a:solidFill>
           <a:ln w="12700">
             <a:solidFill>
-              <a:srgbClr val="1F242E"/>
+              <a:srgbClr val="232A38"/>
             </a:solidFill>
           </a:ln>
         </p:spPr>
@@ -5721,11 +5734,11 @@
             <a:avLst/>
           </a:prstGeom>
           <a:solidFill>
-            <a:srgbClr val="12151C"/>
+            <a:srgbClr val="0E1117"/>
           </a:solidFill>
           <a:ln w="12700">
             <a:solidFill>
-              <a:srgbClr val="1F242E"/>
+              <a:srgbClr val="232A38"/>
             </a:solidFill>
           </a:ln>
         </p:spPr>
@@ -5776,7 +5789,7 @@
             <a:pPr>
               <a:defRPr sz="1300" b="1">
                 <a:solidFill>
-                  <a:srgbClr val="F8FAFC"/>
+                  <a:srgbClr val="FFFFFF"/>
                 </a:solidFill>
                 <a:latin typeface="Arial"/>
               </a:defRPr>
@@ -5873,11 +5886,11 @@
             <a:avLst/>
           </a:prstGeom>
           <a:solidFill>
-            <a:srgbClr val="12151C"/>
+            <a:srgbClr val="0E1117"/>
           </a:solidFill>
           <a:ln w="12700">
             <a:solidFill>
-              <a:srgbClr val="1F242E"/>
+              <a:srgbClr val="232A38"/>
             </a:solidFill>
           </a:ln>
         </p:spPr>
@@ -6043,7 +6056,7 @@
             <a:avLst/>
           </a:prstGeom>
           <a:solidFill>
-            <a:srgbClr val="0B0D11"/>
+            <a:srgbClr val="08090D"/>
           </a:solidFill>
           <a:ln>
             <a:noFill/>
@@ -6096,13 +6109,13 @@
             <a:pPr>
               <a:defRPr sz="950" b="1">
                 <a:solidFill>
-                  <a:srgbClr val="3B82F6"/>
-                </a:solidFill>
-                <a:latin typeface="Arial"/>
-              </a:defRPr>
-            </a:pPr>
-            <a:r>
-              <a:t>MIDNIGHT NETWORK • HACKATHON PITCH DECK</a:t>
+                  <a:srgbClr val="00F5A0"/>
+                </a:solidFill>
+                <a:latin typeface="Arial"/>
+              </a:defRPr>
+            </a:pPr>
+            <a:r>
+              <a:t>KNIGHT.VAULT // ZERO-KNOWLEDGE PROTOCOL DECK</a:t>
             </a:r>
           </a:p>
         </p:txBody>
@@ -6132,7 +6145,7 @@
             <a:pPr>
               <a:defRPr sz="2000" b="1">
                 <a:solidFill>
-                  <a:srgbClr val="F8FAFC"/>
+                  <a:srgbClr val="FFFFFF"/>
                 </a:solidFill>
                 <a:latin typeface="Arial"/>
               </a:defRPr>
@@ -6158,7 +6171,7 @@
             <a:avLst/>
           </a:prstGeom>
           <a:solidFill>
-            <a:srgbClr val="1F242E"/>
+            <a:srgbClr val="232A38"/>
           </a:solidFill>
           <a:ln>
             <a:noFill/>
@@ -6201,11 +6214,11 @@
             <a:avLst/>
           </a:prstGeom>
           <a:solidFill>
-            <a:srgbClr val="12151C"/>
+            <a:srgbClr val="0E1117"/>
           </a:solidFill>
           <a:ln w="12700">
             <a:solidFill>
-              <a:srgbClr val="1F242E"/>
+              <a:srgbClr val="232A38"/>
             </a:solidFill>
           </a:ln>
         </p:spPr>
@@ -6401,11 +6414,11 @@
             <a:avLst/>
           </a:prstGeom>
           <a:solidFill>
-            <a:srgbClr val="12151C"/>
+            <a:srgbClr val="0E1117"/>
           </a:solidFill>
           <a:ln w="12700">
             <a:solidFill>
-              <a:srgbClr val="1F242E"/>
+              <a:srgbClr val="232A38"/>
             </a:solidFill>
           </a:ln>
         </p:spPr>
@@ -6601,11 +6614,11 @@
             <a:avLst/>
           </a:prstGeom>
           <a:solidFill>
-            <a:srgbClr val="12151C"/>
+            <a:srgbClr val="0E1117"/>
           </a:solidFill>
           <a:ln w="12700">
             <a:solidFill>
-              <a:srgbClr val="1F242E"/>
+              <a:srgbClr val="232A38"/>
             </a:solidFill>
           </a:ln>
         </p:spPr>
@@ -6801,11 +6814,11 @@
             <a:avLst/>
           </a:prstGeom>
           <a:solidFill>
-            <a:srgbClr val="161B26"/>
+            <a:srgbClr val="141923"/>
           </a:solidFill>
           <a:ln w="12700">
             <a:solidFill>
-              <a:srgbClr val="1F242E"/>
+              <a:srgbClr val="232A38"/>
             </a:solidFill>
           </a:ln>
         </p:spPr>
@@ -6856,7 +6869,7 @@
             <a:pPr>
               <a:defRPr sz="1300" b="1">
                 <a:solidFill>
-                  <a:srgbClr val="10B981"/>
+                  <a:srgbClr val="00F5A0"/>
                 </a:solidFill>
                 <a:latin typeface="Arial"/>
               </a:defRPr>
@@ -7019,7 +7032,7 @@
             <a:avLst/>
           </a:prstGeom>
           <a:solidFill>
-            <a:srgbClr val="0B0D11"/>
+            <a:srgbClr val="08090D"/>
           </a:solidFill>
           <a:ln>
             <a:noFill/>
@@ -7072,13 +7085,13 @@
             <a:pPr>
               <a:defRPr sz="950" b="1">
                 <a:solidFill>
-                  <a:srgbClr val="3B82F6"/>
-                </a:solidFill>
-                <a:latin typeface="Arial"/>
-              </a:defRPr>
-            </a:pPr>
-            <a:r>
-              <a:t>MIDNIGHT NETWORK • HACKATHON PITCH DECK</a:t>
+                  <a:srgbClr val="00F5A0"/>
+                </a:solidFill>
+                <a:latin typeface="Arial"/>
+              </a:defRPr>
+            </a:pPr>
+            <a:r>
+              <a:t>KNIGHT.VAULT // ZERO-KNOWLEDGE PROTOCOL DECK</a:t>
             </a:r>
           </a:p>
         </p:txBody>
@@ -7108,7 +7121,7 @@
             <a:pPr>
               <a:defRPr sz="2000" b="1">
                 <a:solidFill>
-                  <a:srgbClr val="F8FAFC"/>
+                  <a:srgbClr val="FFFFFF"/>
                 </a:solidFill>
                 <a:latin typeface="Arial"/>
               </a:defRPr>
@@ -7134,7 +7147,7 @@
             <a:avLst/>
           </a:prstGeom>
           <a:solidFill>
-            <a:srgbClr val="1F242E"/>
+            <a:srgbClr val="232A38"/>
           </a:solidFill>
           <a:ln>
             <a:noFill/>
@@ -7177,11 +7190,11 @@
             <a:avLst/>
           </a:prstGeom>
           <a:solidFill>
-            <a:srgbClr val="12151C"/>
+            <a:srgbClr val="0E1117"/>
           </a:solidFill>
           <a:ln w="12700">
             <a:solidFill>
-              <a:srgbClr val="1F242E"/>
+              <a:srgbClr val="232A38"/>
             </a:solidFill>
           </a:ln>
         </p:spPr>
@@ -7232,7 +7245,7 @@
             <a:pPr>
               <a:defRPr sz="1300" b="1">
                 <a:solidFill>
-                  <a:srgbClr val="3B82F6"/>
+                  <a:srgbClr val="818CF8"/>
                 </a:solidFill>
                 <a:latin typeface="Arial"/>
               </a:defRPr>
@@ -7377,11 +7390,11 @@
             <a:avLst/>
           </a:prstGeom>
           <a:solidFill>
-            <a:srgbClr val="12151C"/>
+            <a:srgbClr val="0E1117"/>
           </a:solidFill>
           <a:ln w="12700">
             <a:solidFill>
-              <a:srgbClr val="1F242E"/>
+              <a:srgbClr val="232A38"/>
             </a:solidFill>
           </a:ln>
         </p:spPr>
@@ -7577,11 +7590,11 @@
             <a:avLst/>
           </a:prstGeom>
           <a:solidFill>
-            <a:srgbClr val="12151C"/>
+            <a:srgbClr val="0E1117"/>
           </a:solidFill>
           <a:ln w="12700">
             <a:solidFill>
-              <a:srgbClr val="1F242E"/>
+              <a:srgbClr val="232A38"/>
             </a:solidFill>
           </a:ln>
         </p:spPr>
@@ -7632,7 +7645,7 @@
             <a:pPr>
               <a:defRPr sz="1300" b="1">
                 <a:solidFill>
-                  <a:srgbClr val="10B981"/>
+                  <a:srgbClr val="00F5A0"/>
                 </a:solidFill>
                 <a:latin typeface="Arial"/>
               </a:defRPr>
@@ -7777,11 +7790,11 @@
             <a:avLst/>
           </a:prstGeom>
           <a:solidFill>
-            <a:srgbClr val="12151C"/>
+            <a:srgbClr val="0E1117"/>
           </a:solidFill>
           <a:ln w="12700">
             <a:solidFill>
-              <a:srgbClr val="1F242E"/>
+              <a:srgbClr val="232A38"/>
             </a:solidFill>
           </a:ln>
         </p:spPr>
@@ -7995,7 +8008,7 @@
             <a:avLst/>
           </a:prstGeom>
           <a:solidFill>
-            <a:srgbClr val="0B0D11"/>
+            <a:srgbClr val="08090D"/>
           </a:solidFill>
           <a:ln>
             <a:noFill/>
@@ -8048,13 +8061,13 @@
             <a:pPr>
               <a:defRPr sz="950" b="1">
                 <a:solidFill>
-                  <a:srgbClr val="3B82F6"/>
-                </a:solidFill>
-                <a:latin typeface="Arial"/>
-              </a:defRPr>
-            </a:pPr>
-            <a:r>
-              <a:t>MIDNIGHT NETWORK • HACKATHON PITCH DECK</a:t>
+                  <a:srgbClr val="00F5A0"/>
+                </a:solidFill>
+                <a:latin typeface="Arial"/>
+              </a:defRPr>
+            </a:pPr>
+            <a:r>
+              <a:t>KNIGHT.VAULT // ZERO-KNOWLEDGE PROTOCOL DECK</a:t>
             </a:r>
           </a:p>
         </p:txBody>
@@ -8084,7 +8097,7 @@
             <a:pPr>
               <a:defRPr sz="2000" b="1">
                 <a:solidFill>
-                  <a:srgbClr val="F8FAFC"/>
+                  <a:srgbClr val="FFFFFF"/>
                 </a:solidFill>
                 <a:latin typeface="Arial"/>
               </a:defRPr>
@@ -8110,7 +8123,7 @@
             <a:avLst/>
           </a:prstGeom>
           <a:solidFill>
-            <a:srgbClr val="1F242E"/>
+            <a:srgbClr val="232A38"/>
           </a:solidFill>
           <a:ln>
             <a:noFill/>
@@ -8153,11 +8166,11 @@
             <a:avLst/>
           </a:prstGeom>
           <a:solidFill>
-            <a:srgbClr val="12151C"/>
+            <a:srgbClr val="0E1117"/>
           </a:solidFill>
           <a:ln w="12700">
             <a:solidFill>
-              <a:srgbClr val="1F242E"/>
+              <a:srgbClr val="232A38"/>
             </a:solidFill>
           </a:ln>
         </p:spPr>
@@ -8208,7 +8221,7 @@
             <a:pPr>
               <a:defRPr sz="1300" b="1">
                 <a:solidFill>
-                  <a:srgbClr val="3B82F6"/>
+                  <a:srgbClr val="818CF8"/>
                 </a:solidFill>
                 <a:latin typeface="Arial"/>
               </a:defRPr>
@@ -8321,11 +8334,11 @@
             <a:avLst/>
           </a:prstGeom>
           <a:solidFill>
-            <a:srgbClr val="12151C"/>
+            <a:srgbClr val="0E1117"/>
           </a:solidFill>
           <a:ln w="12700">
             <a:solidFill>
-              <a:srgbClr val="1F242E"/>
+              <a:srgbClr val="232A38"/>
             </a:solidFill>
           </a:ln>
         </p:spPr>
@@ -8376,7 +8389,7 @@
             <a:pPr>
               <a:defRPr sz="1300" b="1">
                 <a:solidFill>
-                  <a:srgbClr val="10B981"/>
+                  <a:srgbClr val="00F5A0"/>
                 </a:solidFill>
                 <a:latin typeface="Arial"/>
               </a:defRPr>
@@ -8507,7 +8520,7 @@
             <a:avLst/>
           </a:prstGeom>
           <a:solidFill>
-            <a:srgbClr val="0B0D11"/>
+            <a:srgbClr val="08090D"/>
           </a:solidFill>
           <a:ln>
             <a:noFill/>
@@ -8560,13 +8573,13 @@
             <a:pPr>
               <a:defRPr sz="950" b="1">
                 <a:solidFill>
-                  <a:srgbClr val="3B82F6"/>
-                </a:solidFill>
-                <a:latin typeface="Arial"/>
-              </a:defRPr>
-            </a:pPr>
-            <a:r>
-              <a:t>MIDNIGHT NETWORK • HACKATHON PITCH DECK</a:t>
+                  <a:srgbClr val="00F5A0"/>
+                </a:solidFill>
+                <a:latin typeface="Arial"/>
+              </a:defRPr>
+            </a:pPr>
+            <a:r>
+              <a:t>KNIGHT.VAULT // ZERO-KNOWLEDGE PROTOCOL DECK</a:t>
             </a:r>
           </a:p>
         </p:txBody>
@@ -8596,7 +8609,7 @@
             <a:pPr>
               <a:defRPr sz="2000" b="1">
                 <a:solidFill>
-                  <a:srgbClr val="F8FAFC"/>
+                  <a:srgbClr val="FFFFFF"/>
                 </a:solidFill>
                 <a:latin typeface="Arial"/>
               </a:defRPr>
@@ -8622,7 +8635,7 @@
             <a:avLst/>
           </a:prstGeom>
           <a:solidFill>
-            <a:srgbClr val="1F242E"/>
+            <a:srgbClr val="232A38"/>
           </a:solidFill>
           <a:ln>
             <a:noFill/>
@@ -8665,11 +8678,11 @@
             <a:avLst/>
           </a:prstGeom>
           <a:solidFill>
-            <a:srgbClr val="12151C"/>
+            <a:srgbClr val="0E1117"/>
           </a:solidFill>
           <a:ln w="12700">
             <a:solidFill>
-              <a:srgbClr val="1F242E"/>
+              <a:srgbClr val="232A38"/>
             </a:solidFill>
           </a:ln>
         </p:spPr>
@@ -8720,7 +8733,7 @@
             <a:pPr>
               <a:defRPr sz="1300" b="1">
                 <a:solidFill>
-                  <a:srgbClr val="3B82F6"/>
+                  <a:srgbClr val="00F5A0"/>
                 </a:solidFill>
                 <a:latin typeface="Arial"/>
               </a:defRPr>
@@ -8785,11 +8798,11 @@
             <a:avLst/>
           </a:prstGeom>
           <a:solidFill>
-            <a:srgbClr val="12151C"/>
+            <a:srgbClr val="0E1117"/>
           </a:solidFill>
           <a:ln w="12700">
             <a:solidFill>
-              <a:srgbClr val="1F242E"/>
+              <a:srgbClr val="232A38"/>
             </a:solidFill>
           </a:ln>
         </p:spPr>
@@ -8840,7 +8853,7 @@
             <a:pPr>
               <a:defRPr sz="1300" b="1">
                 <a:solidFill>
-                  <a:srgbClr val="3B82F6"/>
+                  <a:srgbClr val="00F5A0"/>
                 </a:solidFill>
                 <a:latin typeface="Arial"/>
               </a:defRPr>
@@ -8905,11 +8918,11 @@
             <a:avLst/>
           </a:prstGeom>
           <a:solidFill>
-            <a:srgbClr val="12151C"/>
+            <a:srgbClr val="0E1117"/>
           </a:solidFill>
           <a:ln w="12700">
             <a:solidFill>
-              <a:srgbClr val="1F242E"/>
+              <a:srgbClr val="232A38"/>
             </a:solidFill>
           </a:ln>
         </p:spPr>
@@ -8960,7 +8973,7 @@
             <a:pPr>
               <a:defRPr sz="1300" b="1">
                 <a:solidFill>
-                  <a:srgbClr val="3B82F6"/>
+                  <a:srgbClr val="00F5A0"/>
                 </a:solidFill>
                 <a:latin typeface="Arial"/>
               </a:defRPr>
@@ -9025,11 +9038,11 @@
             <a:avLst/>
           </a:prstGeom>
           <a:solidFill>
-            <a:srgbClr val="12151C"/>
+            <a:srgbClr val="0E1117"/>
           </a:solidFill>
           <a:ln w="12700">
             <a:solidFill>
-              <a:srgbClr val="1F242E"/>
+              <a:srgbClr val="232A38"/>
             </a:solidFill>
           </a:ln>
         </p:spPr>
@@ -9080,7 +9093,7 @@
             <a:pPr>
               <a:defRPr sz="1300" b="1">
                 <a:solidFill>
-                  <a:srgbClr val="3B82F6"/>
+                  <a:srgbClr val="00F5A0"/>
                 </a:solidFill>
                 <a:latin typeface="Arial"/>
               </a:defRPr>
@@ -9163,7 +9176,7 @@
             <a:avLst/>
           </a:prstGeom>
           <a:solidFill>
-            <a:srgbClr val="0B0D11"/>
+            <a:srgbClr val="08090D"/>
           </a:solidFill>
           <a:ln>
             <a:noFill/>
@@ -9216,13 +9229,13 @@
             <a:pPr>
               <a:defRPr sz="950" b="1">
                 <a:solidFill>
-                  <a:srgbClr val="3B82F6"/>
-                </a:solidFill>
-                <a:latin typeface="Arial"/>
-              </a:defRPr>
-            </a:pPr>
-            <a:r>
-              <a:t>MIDNIGHT NETWORK • HACKATHON PITCH DECK</a:t>
+                  <a:srgbClr val="00F5A0"/>
+                </a:solidFill>
+                <a:latin typeface="Arial"/>
+              </a:defRPr>
+            </a:pPr>
+            <a:r>
+              <a:t>KNIGHT.VAULT // ZERO-KNOWLEDGE PROTOCOL DECK</a:t>
             </a:r>
           </a:p>
         </p:txBody>
@@ -9252,7 +9265,7 @@
             <a:pPr>
               <a:defRPr sz="2000" b="1">
                 <a:solidFill>
-                  <a:srgbClr val="F8FAFC"/>
+                  <a:srgbClr val="FFFFFF"/>
                 </a:solidFill>
                 <a:latin typeface="Arial"/>
               </a:defRPr>
@@ -9278,7 +9291,7 @@
             <a:avLst/>
           </a:prstGeom>
           <a:solidFill>
-            <a:srgbClr val="1F242E"/>
+            <a:srgbClr val="232A38"/>
           </a:solidFill>
           <a:ln>
             <a:noFill/>
@@ -9321,11 +9334,11 @@
             <a:avLst/>
           </a:prstGeom>
           <a:solidFill>
-            <a:srgbClr val="12151C"/>
+            <a:srgbClr val="0E1117"/>
           </a:solidFill>
           <a:ln w="12700">
             <a:solidFill>
-              <a:srgbClr val="1F242E"/>
+              <a:srgbClr val="232A38"/>
             </a:solidFill>
           </a:ln>
         </p:spPr>
@@ -9376,7 +9389,7 @@
             <a:pPr>
               <a:defRPr sz="1300" b="1">
                 <a:solidFill>
-                  <a:srgbClr val="3B82F6"/>
+                  <a:srgbClr val="818CF8"/>
                 </a:solidFill>
                 <a:latin typeface="Arial"/>
               </a:defRPr>
@@ -9489,11 +9502,11 @@
             <a:avLst/>
           </a:prstGeom>
           <a:solidFill>
-            <a:srgbClr val="12151C"/>
+            <a:srgbClr val="0E1117"/>
           </a:solidFill>
           <a:ln w="12700">
             <a:solidFill>
-              <a:srgbClr val="1F242E"/>
+              <a:srgbClr val="232A38"/>
             </a:solidFill>
           </a:ln>
         </p:spPr>
@@ -9657,11 +9670,11 @@
             <a:avLst/>
           </a:prstGeom>
           <a:solidFill>
-            <a:srgbClr val="12151C"/>
+            <a:srgbClr val="0E1117"/>
           </a:solidFill>
           <a:ln w="12700">
             <a:solidFill>
-              <a:srgbClr val="1F242E"/>
+              <a:srgbClr val="232A38"/>
             </a:solidFill>
           </a:ln>
         </p:spPr>
@@ -9712,7 +9725,7 @@
             <a:pPr>
               <a:defRPr sz="1300" b="1">
                 <a:solidFill>
-                  <a:srgbClr val="10B981"/>
+                  <a:srgbClr val="00F5A0"/>
                 </a:solidFill>
                 <a:latin typeface="Arial"/>
               </a:defRPr>
@@ -9843,7 +9856,7 @@
             <a:avLst/>
           </a:prstGeom>
           <a:solidFill>
-            <a:srgbClr val="0B0D11"/>
+            <a:srgbClr val="08090D"/>
           </a:solidFill>
           <a:ln>
             <a:noFill/>
@@ -9896,13 +9909,13 @@
             <a:pPr>
               <a:defRPr sz="950" b="1">
                 <a:solidFill>
-                  <a:srgbClr val="3B82F6"/>
-                </a:solidFill>
-                <a:latin typeface="Arial"/>
-              </a:defRPr>
-            </a:pPr>
-            <a:r>
-              <a:t>MIDNIGHT NETWORK • HACKATHON PITCH DECK</a:t>
+                  <a:srgbClr val="00F5A0"/>
+                </a:solidFill>
+                <a:latin typeface="Arial"/>
+              </a:defRPr>
+            </a:pPr>
+            <a:r>
+              <a:t>KNIGHT.VAULT // ZERO-KNOWLEDGE PROTOCOL DECK</a:t>
             </a:r>
           </a:p>
         </p:txBody>
@@ -9932,7 +9945,7 @@
             <a:pPr>
               <a:defRPr sz="2000" b="1">
                 <a:solidFill>
-                  <a:srgbClr val="F8FAFC"/>
+                  <a:srgbClr val="FFFFFF"/>
                 </a:solidFill>
                 <a:latin typeface="Arial"/>
               </a:defRPr>
@@ -9958,7 +9971,7 @@
             <a:avLst/>
           </a:prstGeom>
           <a:solidFill>
-            <a:srgbClr val="1F242E"/>
+            <a:srgbClr val="232A38"/>
           </a:solidFill>
           <a:ln>
             <a:noFill/>
@@ -10001,11 +10014,11 @@
             <a:avLst/>
           </a:prstGeom>
           <a:solidFill>
-            <a:srgbClr val="12151C"/>
+            <a:srgbClr val="0E1117"/>
           </a:solidFill>
           <a:ln w="12700">
             <a:solidFill>
-              <a:srgbClr val="1F242E"/>
+              <a:srgbClr val="232A38"/>
             </a:solidFill>
           </a:ln>
         </p:spPr>
@@ -10056,7 +10069,7 @@
             <a:pPr>
               <a:defRPr sz="1300" b="1">
                 <a:solidFill>
-                  <a:srgbClr val="3B82F6"/>
+                  <a:srgbClr val="818CF8"/>
                 </a:solidFill>
                 <a:latin typeface="Arial"/>
               </a:defRPr>
@@ -10153,11 +10166,11 @@
             <a:avLst/>
           </a:prstGeom>
           <a:solidFill>
-            <a:srgbClr val="12151C"/>
+            <a:srgbClr val="0E1117"/>
           </a:solidFill>
           <a:ln w="12700">
             <a:solidFill>
-              <a:srgbClr val="1F242E"/>
+              <a:srgbClr val="232A38"/>
             </a:solidFill>
           </a:ln>
         </p:spPr>
@@ -10305,11 +10318,11 @@
             <a:avLst/>
           </a:prstGeom>
           <a:solidFill>
-            <a:srgbClr val="12151C"/>
+            <a:srgbClr val="0E1117"/>
           </a:solidFill>
           <a:ln w="12700">
             <a:solidFill>
-              <a:srgbClr val="1F242E"/>
+              <a:srgbClr val="232A38"/>
             </a:solidFill>
           </a:ln>
         </p:spPr>
@@ -10360,7 +10373,7 @@
             <a:pPr>
               <a:defRPr sz="1300" b="1">
                 <a:solidFill>
-                  <a:srgbClr val="10B981"/>
+                  <a:srgbClr val="00F5A0"/>
                 </a:solidFill>
                 <a:latin typeface="Arial"/>
               </a:defRPr>
@@ -10457,11 +10470,11 @@
             <a:avLst/>
           </a:prstGeom>
           <a:solidFill>
-            <a:srgbClr val="12151C"/>
+            <a:srgbClr val="0E1117"/>
           </a:solidFill>
           <a:ln w="12700">
             <a:solidFill>
-              <a:srgbClr val="1F242E"/>
+              <a:srgbClr val="232A38"/>
             </a:solidFill>
           </a:ln>
         </p:spPr>

</xml_diff>

<commit_message>
style(pptx): expand bento cards, enlarge typography, and clean up Compact Circuits labeling
</commit_message>
<xml_diff>
--- a/Midnight_Privacy_Payment_Vault_Presentation.pptx
+++ b/Midnight_Privacy_Payment_Vault_Presentation.pptx
@@ -3144,8 +3144,8 @@
         </p:nvSpPr>
         <p:spPr>
           <a:xfrm>
-            <a:off x="914400" y="1005840"/>
-            <a:ext cx="10332720" cy="320040"/>
+            <a:off x="731520" y="822960"/>
+            <a:ext cx="10728655" cy="320040"/>
           </a:xfrm>
           <a:prstGeom prst="rect">
             <a:avLst/>
@@ -3159,7 +3159,7 @@
           <a:lstStyle/>
           <a:p>
             <a:pPr>
-              <a:defRPr sz="1050" b="1">
+              <a:defRPr sz="1100" b="1">
                 <a:solidFill>
                   <a:srgbClr val="00F5A0"/>
                 </a:solidFill>
@@ -3180,8 +3180,8 @@
         </p:nvSpPr>
         <p:spPr>
           <a:xfrm>
-            <a:off x="914400" y="1325880"/>
-            <a:ext cx="10332720" cy="2011680"/>
+            <a:off x="731520" y="1188720"/>
+            <a:ext cx="10728655" cy="2011680"/>
           </a:xfrm>
           <a:prstGeom prst="rect">
             <a:avLst/>
@@ -3198,7 +3198,7 @@
               <a:spcAft>
                 <a:spcPts val="800"/>
               </a:spcAft>
-              <a:defRPr sz="4000" b="1">
+              <a:defRPr sz="4400" b="1">
                 <a:solidFill>
                   <a:srgbClr val="FFFFFF"/>
                 </a:solidFill>
@@ -3206,20 +3206,20 @@
               </a:defRPr>
             </a:pPr>
             <a:r>
-              <a:t>KNIGHT.VAULT (v0.20)</a:t>
-            </a:r>
-          </a:p>
-          <a:p>
-            <a:pPr>
-              <a:defRPr sz="1400">
-                <a:solidFill>
-                  <a:srgbClr val="94A3B8"/>
+              <a:t>KNIGHT.VAULT</a:t>
+            </a:r>
+          </a:p>
+          <a:p>
+            <a:pPr>
+              <a:defRPr sz="1500">
+                <a:solidFill>
+                  <a:srgbClr val="A0AEC0"/>
                 </a:solidFill>
                 <a:latin typeface="Arial"/>
               </a:defRPr>
             </a:pPr>
             <a:r>
-              <a:t>Institutional Zero-Knowledge Custody, Compact Smart Contracts, ProofStation 0-Gas Balancing, and Armored Privacy.</a:t>
+              <a:t>Institutional Zero-Knowledge Custody, Compact Smart Contracts, ProofStation 0-Gas Balancing, and Armored State Privacy.</a:t>
             </a:r>
           </a:p>
         </p:txBody>
@@ -3232,8 +3232,8 @@
         </p:nvSpPr>
         <p:spPr>
           <a:xfrm>
-            <a:off x="914400" y="3474720"/>
-            <a:ext cx="2450592" cy="1463040"/>
+            <a:off x="731520" y="3383280"/>
+            <a:ext cx="2542032" cy="1600200"/>
           </a:xfrm>
           <a:prstGeom prst="roundRect">
             <a:avLst/>
@@ -3277,8 +3277,8 @@
         </p:nvSpPr>
         <p:spPr>
           <a:xfrm>
-            <a:off x="1051560" y="3611880"/>
-            <a:ext cx="2176272" cy="1188720"/>
+            <a:off x="914400" y="3520440"/>
+            <a:ext cx="2176272" cy="1280160"/>
           </a:xfrm>
           <a:prstGeom prst="rect">
             <a:avLst/>
@@ -3295,9 +3295,9 @@
               <a:spcAft>
                 <a:spcPts val="400"/>
               </a:spcAft>
-              <a:defRPr sz="850" b="1">
-                <a:solidFill>
-                  <a:srgbClr val="64748B"/>
+              <a:defRPr sz="900" b="1">
+                <a:solidFill>
+                  <a:srgbClr val="6E7E96"/>
                 </a:solidFill>
                 <a:latin typeface="Arial"/>
               </a:defRPr>
@@ -3309,9 +3309,9 @@
           <a:p>
             <a:pPr>
               <a:spcAft>
-                <a:spcPts val="200"/>
+                <a:spcPts val="300"/>
               </a:spcAft>
-              <a:defRPr sz="1300" b="1">
+              <a:defRPr sz="1400" b="1">
                 <a:solidFill>
                   <a:srgbClr val="00F5A0"/>
                 </a:solidFill>
@@ -3324,15 +3324,15 @@
           </a:p>
           <a:p>
             <a:pPr>
-              <a:defRPr sz="900">
-                <a:solidFill>
-                  <a:srgbClr val="94A3B8"/>
+              <a:defRPr sz="1000">
+                <a:solidFill>
+                  <a:srgbClr val="A0AEC0"/>
                 </a:solidFill>
                 <a:latin typeface="Arial"/>
               </a:defRPr>
             </a:pPr>
             <a:r>
-              <a:t>Live Partnerchain v0.20</a:t>
+              <a:t>Live Partnerchain Network</a:t>
             </a:r>
           </a:p>
         </p:txBody>
@@ -3345,8 +3345,8 @@
         </p:nvSpPr>
         <p:spPr>
           <a:xfrm>
-            <a:off x="3566160" y="3474720"/>
-            <a:ext cx="2450592" cy="1463040"/>
+            <a:off x="3474720" y="3383280"/>
+            <a:ext cx="2542032" cy="1600200"/>
           </a:xfrm>
           <a:prstGeom prst="roundRect">
             <a:avLst/>
@@ -3390,8 +3390,8 @@
         </p:nvSpPr>
         <p:spPr>
           <a:xfrm>
-            <a:off x="3703320" y="3611880"/>
-            <a:ext cx="2176272" cy="1188720"/>
+            <a:off x="3657600" y="3520440"/>
+            <a:ext cx="2176272" cy="1280160"/>
           </a:xfrm>
           <a:prstGeom prst="rect">
             <a:avLst/>
@@ -3408,9 +3408,9 @@
               <a:spcAft>
                 <a:spcPts val="400"/>
               </a:spcAft>
-              <a:defRPr sz="850" b="1">
-                <a:solidFill>
-                  <a:srgbClr val="64748B"/>
+              <a:defRPr sz="900" b="1">
+                <a:solidFill>
+                  <a:srgbClr val="6E7E96"/>
                 </a:solidFill>
                 <a:latin typeface="Arial"/>
               </a:defRPr>
@@ -3422,9 +3422,9 @@
           <a:p>
             <a:pPr>
               <a:spcAft>
-                <a:spcPts val="200"/>
+                <a:spcPts val="300"/>
               </a:spcAft>
-              <a:defRPr sz="1300" b="1">
+              <a:defRPr sz="1400" b="1">
                 <a:solidFill>
                   <a:srgbClr val="818CF8"/>
                 </a:solidFill>
@@ -3432,14 +3432,14 @@
               </a:defRPr>
             </a:pPr>
             <a:r>
-              <a:t>Compact v0.20+</a:t>
-            </a:r>
-          </a:p>
-          <a:p>
-            <a:pPr>
-              <a:defRPr sz="900">
-                <a:solidFill>
-                  <a:srgbClr val="94A3B8"/>
+              <a:t>Compact Circuits</a:t>
+            </a:r>
+          </a:p>
+          <a:p>
+            <a:pPr>
+              <a:defRPr sz="1000">
+                <a:solidFill>
+                  <a:srgbClr val="A0AEC0"/>
                 </a:solidFill>
                 <a:latin typeface="Arial"/>
               </a:defRPr>
@@ -3458,8 +3458,8 @@
         </p:nvSpPr>
         <p:spPr>
           <a:xfrm>
-            <a:off x="6217920" y="3474720"/>
-            <a:ext cx="2450592" cy="1463040"/>
+            <a:off x="6217920" y="3383280"/>
+            <a:ext cx="2542032" cy="1600200"/>
           </a:xfrm>
           <a:prstGeom prst="roundRect">
             <a:avLst/>
@@ -3503,8 +3503,8 @@
         </p:nvSpPr>
         <p:spPr>
           <a:xfrm>
-            <a:off x="6355080" y="3611880"/>
-            <a:ext cx="2176272" cy="1188720"/>
+            <a:off x="6400800" y="3520440"/>
+            <a:ext cx="2176272" cy="1280160"/>
           </a:xfrm>
           <a:prstGeom prst="rect">
             <a:avLst/>
@@ -3521,9 +3521,9 @@
               <a:spcAft>
                 <a:spcPts val="400"/>
               </a:spcAft>
-              <a:defRPr sz="850" b="1">
-                <a:solidFill>
-                  <a:srgbClr val="64748B"/>
+              <a:defRPr sz="900" b="1">
+                <a:solidFill>
+                  <a:srgbClr val="6E7E96"/>
                 </a:solidFill>
                 <a:latin typeface="Arial"/>
               </a:defRPr>
@@ -3535,9 +3535,9 @@
           <a:p>
             <a:pPr>
               <a:spcAft>
-                <a:spcPts val="200"/>
+                <a:spcPts val="300"/>
               </a:spcAft>
-              <a:defRPr sz="1300" b="1">
+              <a:defRPr sz="1400" b="1">
                 <a:solidFill>
                   <a:srgbClr val="38BDF8"/>
                 </a:solidFill>
@@ -3550,9 +3550,9 @@
           </a:p>
           <a:p>
             <a:pPr>
-              <a:defRPr sz="900">
-                <a:solidFill>
-                  <a:srgbClr val="94A3B8"/>
+              <a:defRPr sz="1000">
+                <a:solidFill>
+                  <a:srgbClr val="A0AEC0"/>
                 </a:solidFill>
                 <a:latin typeface="Arial"/>
               </a:defRPr>
@@ -3571,8 +3571,8 @@
         </p:nvSpPr>
         <p:spPr>
           <a:xfrm>
-            <a:off x="8869680" y="3474720"/>
-            <a:ext cx="2450592" cy="1463040"/>
+            <a:off x="8961120" y="3383280"/>
+            <a:ext cx="2542032" cy="1600200"/>
           </a:xfrm>
           <a:prstGeom prst="roundRect">
             <a:avLst/>
@@ -3616,8 +3616,8 @@
         </p:nvSpPr>
         <p:spPr>
           <a:xfrm>
-            <a:off x="9006840" y="3611880"/>
-            <a:ext cx="2176272" cy="1188720"/>
+            <a:off x="9144000" y="3520440"/>
+            <a:ext cx="2176272" cy="1280160"/>
           </a:xfrm>
           <a:prstGeom prst="rect">
             <a:avLst/>
@@ -3634,9 +3634,9 @@
               <a:spcAft>
                 <a:spcPts val="400"/>
               </a:spcAft>
-              <a:defRPr sz="850" b="1">
-                <a:solidFill>
-                  <a:srgbClr val="64748B"/>
+              <a:defRPr sz="900" b="1">
+                <a:solidFill>
+                  <a:srgbClr val="6E7E96"/>
                 </a:solidFill>
                 <a:latin typeface="Arial"/>
               </a:defRPr>
@@ -3648,9 +3648,9 @@
           <a:p>
             <a:pPr>
               <a:spcAft>
-                <a:spcPts val="200"/>
+                <a:spcPts val="300"/>
               </a:spcAft>
-              <a:defRPr sz="1300" b="1">
+              <a:defRPr sz="1400" b="1">
                 <a:solidFill>
                   <a:srgbClr val="10B981"/>
                 </a:solidFill>
@@ -3663,9 +3663,9 @@
           </a:p>
           <a:p>
             <a:pPr>
-              <a:defRPr sz="900">
-                <a:solidFill>
-                  <a:srgbClr val="94A3B8"/>
+              <a:defRPr sz="1000">
+                <a:solidFill>
+                  <a:srgbClr val="A0AEC0"/>
                 </a:solidFill>
                 <a:latin typeface="Arial"/>
               </a:defRPr>
@@ -3684,8 +3684,8 @@
         </p:nvSpPr>
         <p:spPr>
           <a:xfrm>
-            <a:off x="914400" y="5166360"/>
-            <a:ext cx="10362895" cy="1097280"/>
+            <a:off x="731520" y="5166360"/>
+            <a:ext cx="10728655" cy="1188720"/>
           </a:xfrm>
           <a:prstGeom prst="roundRect">
             <a:avLst/>
@@ -3729,8 +3729,8 @@
         </p:nvSpPr>
         <p:spPr>
           <a:xfrm>
-            <a:off x="1143000" y="5257800"/>
-            <a:ext cx="9875520" cy="868680"/>
+            <a:off x="1005840" y="5257800"/>
+            <a:ext cx="10241280" cy="960120"/>
           </a:xfrm>
           <a:prstGeom prst="rect">
             <a:avLst/>
@@ -3745,9 +3745,9 @@
           <a:p>
             <a:pPr>
               <a:spcAft>
-                <a:spcPts val="300"/>
+                <a:spcPts val="400"/>
               </a:spcAft>
-              <a:defRPr sz="1100" b="1">
+              <a:defRPr sz="1200" b="1">
                 <a:solidFill>
                   <a:srgbClr val="00F5A0"/>
                 </a:solidFill>
@@ -3760,15 +3760,15 @@
           </a:p>
           <a:p>
             <a:pPr>
-              <a:defRPr sz="950">
-                <a:solidFill>
-                  <a:srgbClr val="94A3B8"/>
+              <a:defRPr sz="1050">
+                <a:solidFill>
+                  <a:srgbClr val="A0AEC0"/>
                 </a:solidFill>
                 <a:latin typeface="Arial"/>
               </a:defRPr>
             </a:pPr>
             <a:r>
-              <a:t>Stack: Compact Circuits • Halo2 Proofs • Midnight.js SDK • 1AM Wallet • React 18 • Vite • Tailwind Kinetic UI</a:t>
+              <a:t>Stack: Compact Smart Contracts • Halo2 Proofs • Midnight.js SDK • 1AM Wallet • React 18 • Vite • Tailwind Kinetic UI</a:t>
             </a:r>
           </a:p>
         </p:txBody>
@@ -3843,7 +3843,7 @@
         <p:spPr>
           <a:xfrm>
             <a:off x="731520" y="365760"/>
-            <a:ext cx="10698480" cy="292608"/>
+            <a:ext cx="10698480" cy="320040"/>
           </a:xfrm>
           <a:prstGeom prst="rect">
             <a:avLst/>
@@ -3857,7 +3857,7 @@
           <a:lstStyle/>
           <a:p>
             <a:pPr>
-              <a:defRPr sz="950" b="1">
+              <a:defRPr sz="1000" b="1">
                 <a:solidFill>
                   <a:srgbClr val="00F5A0"/>
                 </a:solidFill>
@@ -3879,7 +3879,7 @@
         <p:spPr>
           <a:xfrm>
             <a:off x="731520" y="658368"/>
-            <a:ext cx="10698480" cy="594360"/>
+            <a:ext cx="10698480" cy="640080"/>
           </a:xfrm>
           <a:prstGeom prst="rect">
             <a:avLst/>
@@ -3893,7 +3893,7 @@
           <a:lstStyle/>
           <a:p>
             <a:pPr>
-              <a:defRPr sz="2200" b="1">
+              <a:defRPr sz="2400" b="1">
                 <a:solidFill>
                   <a:srgbClr val="FFFFFF"/>
                 </a:solidFill>
@@ -3914,8 +3914,8 @@
         </p:nvSpPr>
         <p:spPr>
           <a:xfrm>
-            <a:off x="731520" y="1298448"/>
-            <a:ext cx="10728655" cy="13716"/>
+            <a:off x="731520" y="1325880"/>
+            <a:ext cx="10728655" cy="16459"/>
           </a:xfrm>
           <a:prstGeom prst="rect">
             <a:avLst/>
@@ -3957,8 +3957,8 @@
         </p:nvSpPr>
         <p:spPr>
           <a:xfrm>
-            <a:off x="731520" y="1298448"/>
-            <a:ext cx="1097280" cy="22860"/>
+            <a:off x="731520" y="1325880"/>
+            <a:ext cx="1371600" cy="27432"/>
           </a:xfrm>
           <a:prstGeom prst="rect">
             <a:avLst/>
@@ -4000,8 +4000,8 @@
         </p:nvSpPr>
         <p:spPr>
           <a:xfrm>
-            <a:off x="731520" y="1645920"/>
-            <a:ext cx="5212080" cy="4572000"/>
+            <a:off x="731520" y="1600200"/>
+            <a:ext cx="5257800" cy="4754880"/>
           </a:xfrm>
           <a:prstGeom prst="roundRect">
             <a:avLst/>
@@ -4045,8 +4045,8 @@
         </p:nvSpPr>
         <p:spPr>
           <a:xfrm>
-            <a:off x="960120" y="1645920"/>
-            <a:ext cx="1645920" cy="36576"/>
+            <a:off x="1005840" y="1600200"/>
+            <a:ext cx="2011680" cy="41148"/>
           </a:xfrm>
           <a:prstGeom prst="roundRect">
             <a:avLst/>
@@ -4088,8 +4088,8 @@
         </p:nvSpPr>
         <p:spPr>
           <a:xfrm>
-            <a:off x="960120" y="1828800"/>
-            <a:ext cx="4754880" cy="256032"/>
+            <a:off x="1005840" y="1801368"/>
+            <a:ext cx="4709160" cy="274320"/>
           </a:xfrm>
           <a:prstGeom prst="rect">
             <a:avLst/>
@@ -4103,7 +4103,7 @@
           <a:lstStyle/>
           <a:p>
             <a:pPr>
-              <a:defRPr sz="850" b="1">
+              <a:defRPr sz="900" b="1">
                 <a:solidFill>
                   <a:srgbClr val="F43F5E"/>
                 </a:solidFill>
@@ -4124,8 +4124,8 @@
         </p:nvSpPr>
         <p:spPr>
           <a:xfrm>
-            <a:off x="960120" y="2084832"/>
-            <a:ext cx="4754880" cy="411480"/>
+            <a:off x="1005840" y="2075688"/>
+            <a:ext cx="4709160" cy="457200"/>
           </a:xfrm>
           <a:prstGeom prst="rect">
             <a:avLst/>
@@ -4139,7 +4139,7 @@
           <a:lstStyle/>
           <a:p>
             <a:pPr>
-              <a:defRPr sz="1300" b="1">
+              <a:defRPr sz="1500" b="1">
                 <a:solidFill>
                   <a:srgbClr val="FFFFFF"/>
                 </a:solidFill>
@@ -4160,8 +4160,8 @@
         </p:nvSpPr>
         <p:spPr>
           <a:xfrm>
-            <a:off x="960120" y="2496312"/>
-            <a:ext cx="4754880" cy="3584448"/>
+            <a:off x="1005840" y="2551176"/>
+            <a:ext cx="4709160" cy="3666744"/>
           </a:xfrm>
           <a:prstGeom prst="rect">
             <a:avLst/>
@@ -4176,11 +4176,11 @@
           <a:p>
             <a:pPr>
               <a:spcAft>
-                <a:spcPts val="500"/>
+                <a:spcPts val="1200"/>
               </a:spcAft>
-              <a:defRPr sz="1000">
-                <a:solidFill>
-                  <a:srgbClr val="94A3B8"/>
+              <a:defRPr sz="1200">
+                <a:solidFill>
+                  <a:srgbClr val="A0AEC0"/>
                 </a:solidFill>
                 <a:latin typeface="Arial"/>
               </a:defRPr>
@@ -4192,27 +4192,27 @@
           <a:p>
             <a:pPr>
               <a:spcAft>
-                <a:spcPts val="500"/>
+                <a:spcPts val="1200"/>
               </a:spcAft>
-              <a:defRPr sz="1000">
-                <a:solidFill>
-                  <a:srgbClr val="94A3B8"/>
+              <a:defRPr sz="1200">
+                <a:solidFill>
+                  <a:srgbClr val="A0AEC0"/>
                 </a:solidFill>
                 <a:latin typeface="Arial"/>
               </a:defRPr>
             </a:pPr>
             <a:r>
-              <a:t>•  Gas-Trail De-Anonymization: Purchasing native gas tokens creates an irreversible KYC link to every on-chain activity.</a:t>
+              <a:t>•  Gas-Trail De-Anonymization: Purchasing native gas tokens creates an irreversible KYC link to every on-chain move.</a:t>
             </a:r>
           </a:p>
           <a:p>
             <a:pPr>
               <a:spcAft>
-                <a:spcPts val="500"/>
+                <a:spcPts val="1200"/>
               </a:spcAft>
-              <a:defRPr sz="1000">
-                <a:solidFill>
-                  <a:srgbClr val="94A3B8"/>
+              <a:defRPr sz="1200">
+                <a:solidFill>
+                  <a:srgbClr val="A0AEC0"/>
                 </a:solidFill>
                 <a:latin typeface="Arial"/>
               </a:defRPr>
@@ -4224,17 +4224,17 @@
           <a:p>
             <a:pPr>
               <a:spcAft>
-                <a:spcPts val="500"/>
+                <a:spcPts val="1200"/>
               </a:spcAft>
-              <a:defRPr sz="1000">
-                <a:solidFill>
-                  <a:srgbClr val="94A3B8"/>
+              <a:defRPr sz="1200">
+                <a:solidFill>
+                  <a:srgbClr val="A0AEC0"/>
                 </a:solidFill>
                 <a:latin typeface="Arial"/>
               </a:defRPr>
             </a:pPr>
             <a:r>
-              <a:t>•  Enterprise Blockade: Fortune 500 companies cannot execute business settlements on public blockchains without leaking corporate secrets.</a:t>
+              <a:t>•  Enterprise Blockade: Global enterprises cannot execute confidential settlements on public blockchains without leaking corporate data.</a:t>
             </a:r>
           </a:p>
         </p:txBody>
@@ -4247,8 +4247,8 @@
         </p:nvSpPr>
         <p:spPr>
           <a:xfrm>
-            <a:off x="6248095" y="1645920"/>
-            <a:ext cx="5212080" cy="4572000"/>
+            <a:off x="6199632" y="1600200"/>
+            <a:ext cx="5257800" cy="4754880"/>
           </a:xfrm>
           <a:prstGeom prst="roundRect">
             <a:avLst/>
@@ -4292,8 +4292,8 @@
         </p:nvSpPr>
         <p:spPr>
           <a:xfrm>
-            <a:off x="6476695" y="1645920"/>
-            <a:ext cx="1645920" cy="36576"/>
+            <a:off x="6473952" y="1600200"/>
+            <a:ext cx="2011680" cy="41148"/>
           </a:xfrm>
           <a:prstGeom prst="roundRect">
             <a:avLst/>
@@ -4335,8 +4335,8 @@
         </p:nvSpPr>
         <p:spPr>
           <a:xfrm>
-            <a:off x="6476695" y="1828800"/>
-            <a:ext cx="4754880" cy="256032"/>
+            <a:off x="6473952" y="1801368"/>
+            <a:ext cx="4709160" cy="274320"/>
           </a:xfrm>
           <a:prstGeom prst="rect">
             <a:avLst/>
@@ -4350,7 +4350,7 @@
           <a:lstStyle/>
           <a:p>
             <a:pPr>
-              <a:defRPr sz="850" b="1">
+              <a:defRPr sz="900" b="1">
                 <a:solidFill>
                   <a:srgbClr val="00F5A0"/>
                 </a:solidFill>
@@ -4371,8 +4371,8 @@
         </p:nvSpPr>
         <p:spPr>
           <a:xfrm>
-            <a:off x="6476695" y="2084832"/>
-            <a:ext cx="4754880" cy="411480"/>
+            <a:off x="6473952" y="2075688"/>
+            <a:ext cx="4709160" cy="457200"/>
           </a:xfrm>
           <a:prstGeom prst="rect">
             <a:avLst/>
@@ -4386,7 +4386,7 @@
           <a:lstStyle/>
           <a:p>
             <a:pPr>
-              <a:defRPr sz="1300" b="1">
+              <a:defRPr sz="1500" b="1">
                 <a:solidFill>
                   <a:srgbClr val="FFFFFF"/>
                 </a:solidFill>
@@ -4407,8 +4407,8 @@
         </p:nvSpPr>
         <p:spPr>
           <a:xfrm>
-            <a:off x="6476695" y="2496312"/>
-            <a:ext cx="4754880" cy="3584448"/>
+            <a:off x="6473952" y="2551176"/>
+            <a:ext cx="4709160" cy="3666744"/>
           </a:xfrm>
           <a:prstGeom prst="rect">
             <a:avLst/>
@@ -4423,11 +4423,11 @@
           <a:p>
             <a:pPr>
               <a:spcAft>
-                <a:spcPts val="500"/>
+                <a:spcPts val="1200"/>
               </a:spcAft>
-              <a:defRPr sz="1000">
-                <a:solidFill>
-                  <a:srgbClr val="94A3B8"/>
+              <a:defRPr sz="1200">
+                <a:solidFill>
+                  <a:srgbClr val="A0AEC0"/>
                 </a:solidFill>
                 <a:latin typeface="Arial"/>
               </a:defRPr>
@@ -4439,11 +4439,11 @@
           <a:p>
             <a:pPr>
               <a:spcAft>
-                <a:spcPts val="500"/>
+                <a:spcPts val="1200"/>
               </a:spcAft>
-              <a:defRPr sz="1000">
-                <a:solidFill>
-                  <a:srgbClr val="94A3B8"/>
+              <a:defRPr sz="1200">
+                <a:solidFill>
+                  <a:srgbClr val="A0AEC0"/>
                 </a:solidFill>
                 <a:latin typeface="Arial"/>
               </a:defRPr>
@@ -4455,27 +4455,27 @@
           <a:p>
             <a:pPr>
               <a:spcAft>
-                <a:spcPts val="500"/>
+                <a:spcPts val="1200"/>
               </a:spcAft>
-              <a:defRPr sz="1000">
-                <a:solidFill>
-                  <a:srgbClr val="94A3B8"/>
+              <a:defRPr sz="1200">
+                <a:solidFill>
+                  <a:srgbClr val="A0AEC0"/>
                 </a:solidFill>
                 <a:latin typeface="Arial"/>
               </a:defRPr>
             </a:pPr>
             <a:r>
-              <a:t>•  Deterministic Ledger Accounting: Public counters track verified settlement totals while protecting individual transactor identities.</a:t>
+              <a:t>•  Deterministic Ledger Accounting: Public counters track verified settlement totals while protecting transactor identities.</a:t>
             </a:r>
           </a:p>
           <a:p>
             <a:pPr>
               <a:spcAft>
-                <a:spcPts val="500"/>
+                <a:spcPts val="1200"/>
               </a:spcAft>
-              <a:defRPr sz="1000">
-                <a:solidFill>
-                  <a:srgbClr val="94A3B8"/>
+              <a:defRPr sz="1200">
+                <a:solidFill>
+                  <a:srgbClr val="A0AEC0"/>
                 </a:solidFill>
                 <a:latin typeface="Arial"/>
               </a:defRPr>
@@ -4556,7 +4556,7 @@
         <p:spPr>
           <a:xfrm>
             <a:off x="731520" y="365760"/>
-            <a:ext cx="10698480" cy="292608"/>
+            <a:ext cx="10698480" cy="320040"/>
           </a:xfrm>
           <a:prstGeom prst="rect">
             <a:avLst/>
@@ -4570,7 +4570,7 @@
           <a:lstStyle/>
           <a:p>
             <a:pPr>
-              <a:defRPr sz="950" b="1">
+              <a:defRPr sz="1000" b="1">
                 <a:solidFill>
                   <a:srgbClr val="00F5A0"/>
                 </a:solidFill>
@@ -4592,7 +4592,7 @@
         <p:spPr>
           <a:xfrm>
             <a:off x="731520" y="658368"/>
-            <a:ext cx="10698480" cy="594360"/>
+            <a:ext cx="10698480" cy="640080"/>
           </a:xfrm>
           <a:prstGeom prst="rect">
             <a:avLst/>
@@ -4606,7 +4606,7 @@
           <a:lstStyle/>
           <a:p>
             <a:pPr>
-              <a:defRPr sz="2200" b="1">
+              <a:defRPr sz="2400" b="1">
                 <a:solidFill>
                   <a:srgbClr val="FFFFFF"/>
                 </a:solidFill>
@@ -4614,7 +4614,7 @@
               </a:defRPr>
             </a:pPr>
             <a:r>
-              <a:t>Compact v0.20 Smart Contract Architecture</a:t>
+              <a:t>Compact Smart Contract Architecture</a:t>
             </a:r>
           </a:p>
         </p:txBody>
@@ -4627,8 +4627,8 @@
         </p:nvSpPr>
         <p:spPr>
           <a:xfrm>
-            <a:off x="731520" y="1298448"/>
-            <a:ext cx="10728655" cy="13716"/>
+            <a:off x="731520" y="1325880"/>
+            <a:ext cx="10728655" cy="16459"/>
           </a:xfrm>
           <a:prstGeom prst="rect">
             <a:avLst/>
@@ -4670,8 +4670,8 @@
         </p:nvSpPr>
         <p:spPr>
           <a:xfrm>
-            <a:off x="731520" y="1298448"/>
-            <a:ext cx="1097280" cy="22860"/>
+            <a:off x="731520" y="1325880"/>
+            <a:ext cx="1371600" cy="27432"/>
           </a:xfrm>
           <a:prstGeom prst="rect">
             <a:avLst/>
@@ -4713,8 +4713,8 @@
         </p:nvSpPr>
         <p:spPr>
           <a:xfrm>
-            <a:off x="731520" y="1645920"/>
-            <a:ext cx="6217920" cy="4572000"/>
+            <a:off x="731520" y="1600200"/>
+            <a:ext cx="6217920" cy="4754880"/>
           </a:xfrm>
           <a:prstGeom prst="roundRect">
             <a:avLst/>
@@ -4758,8 +4758,8 @@
         </p:nvSpPr>
         <p:spPr>
           <a:xfrm>
-            <a:off x="914400" y="1783080"/>
-            <a:ext cx="5852160" cy="4297680"/>
+            <a:off x="914400" y="1737360"/>
+            <a:ext cx="5852160" cy="4434840"/>
           </a:xfrm>
           <a:prstGeom prst="rect">
             <a:avLst/>
@@ -4774,25 +4774,25 @@
           <a:p>
             <a:pPr>
               <a:spcAft>
-                <a:spcPts val="150"/>
+                <a:spcPts val="200"/>
               </a:spcAft>
-              <a:defRPr sz="850">
-                <a:solidFill>
-                  <a:srgbClr val="64748B"/>
+              <a:defRPr sz="950">
+                <a:solidFill>
+                  <a:srgbClr val="6E7E96"/>
                 </a:solidFill>
                 <a:latin typeface="Consolas"/>
               </a:defRPr>
             </a:pPr>
             <a:r>
-              <a:t>// payment.compact (Midnight Network stdlib v0.20)</a:t>
+              <a:t>// payment.compact (Midnight Network stdlib)</a:t>
             </a:r>
           </a:p>
           <a:p>
             <a:pPr>
               <a:spcAft>
-                <a:spcPts val="150"/>
+                <a:spcPts val="200"/>
               </a:spcAft>
-              <a:defRPr sz="850">
+              <a:defRPr sz="950">
                 <a:solidFill>
                   <a:srgbClr val="FFFFFF"/>
                 </a:solidFill>
@@ -4806,9 +4806,9 @@
           <a:p>
             <a:pPr>
               <a:spcAft>
-                <a:spcPts val="150"/>
+                <a:spcPts val="200"/>
               </a:spcAft>
-              <a:defRPr sz="850">
+              <a:defRPr sz="950">
                 <a:solidFill>
                   <a:srgbClr val="00F5A0"/>
                 </a:solidFill>
@@ -4822,9 +4822,9 @@
           <a:p>
             <a:pPr>
               <a:spcAft>
-                <a:spcPts val="150"/>
+                <a:spcPts val="200"/>
               </a:spcAft>
-              <a:defRPr sz="850">
+              <a:defRPr sz="950">
                 <a:solidFill>
                   <a:srgbClr val="00F5A0"/>
                 </a:solidFill>
@@ -4838,9 +4838,9 @@
           <a:p>
             <a:pPr>
               <a:spcAft>
-                <a:spcPts val="150"/>
+                <a:spcPts val="200"/>
               </a:spcAft>
-              <a:defRPr sz="850">
+              <a:defRPr sz="950">
                 <a:solidFill>
                   <a:srgbClr val="00F5A0"/>
                 </a:solidFill>
@@ -4854,9 +4854,9 @@
           <a:p>
             <a:pPr>
               <a:spcAft>
-                <a:spcPts val="150"/>
+                <a:spcPts val="200"/>
               </a:spcAft>
-              <a:defRPr sz="850">
+              <a:defRPr sz="950">
                 <a:solidFill>
                   <a:srgbClr val="FFFFFF"/>
                 </a:solidFill>
@@ -4867,11 +4867,11 @@
           <a:p>
             <a:pPr>
               <a:spcAft>
-                <a:spcPts val="150"/>
+                <a:spcPts val="200"/>
               </a:spcAft>
-              <a:defRPr sz="850">
-                <a:solidFill>
-                  <a:srgbClr val="64748B"/>
+              <a:defRPr sz="950">
+                <a:solidFill>
+                  <a:srgbClr val="6E7E96"/>
                 </a:solidFill>
                 <a:latin typeface="Consolas"/>
               </a:defRPr>
@@ -4883,9 +4883,9 @@
           <a:p>
             <a:pPr>
               <a:spcAft>
-                <a:spcPts val="150"/>
+                <a:spcPts val="200"/>
               </a:spcAft>
-              <a:defRPr sz="850">
+              <a:defRPr sz="950">
                 <a:solidFill>
                   <a:srgbClr val="38BDF8"/>
                 </a:solidFill>
@@ -4899,9 +4899,9 @@
           <a:p>
             <a:pPr>
               <a:spcAft>
-                <a:spcPts val="150"/>
+                <a:spcPts val="200"/>
               </a:spcAft>
-              <a:defRPr sz="850">
+              <a:defRPr sz="950">
                 <a:solidFill>
                   <a:srgbClr val="F1F5F9"/>
                 </a:solidFill>
@@ -4915,9 +4915,9 @@
           <a:p>
             <a:pPr>
               <a:spcAft>
-                <a:spcPts val="150"/>
+                <a:spcPts val="200"/>
               </a:spcAft>
-              <a:defRPr sz="850">
+              <a:defRPr sz="950">
                 <a:solidFill>
                   <a:srgbClr val="F1F5F9"/>
                 </a:solidFill>
@@ -4931,9 +4931,9 @@
           <a:p>
             <a:pPr>
               <a:spcAft>
-                <a:spcPts val="150"/>
+                <a:spcPts val="200"/>
               </a:spcAft>
-              <a:defRPr sz="850">
+              <a:defRPr sz="950">
                 <a:solidFill>
                   <a:srgbClr val="38BDF8"/>
                 </a:solidFill>
@@ -4947,9 +4947,9 @@
           <a:p>
             <a:pPr>
               <a:spcAft>
-                <a:spcPts val="150"/>
+                <a:spcPts val="200"/>
               </a:spcAft>
-              <a:defRPr sz="850">
+              <a:defRPr sz="950">
                 <a:solidFill>
                   <a:srgbClr val="FFFFFF"/>
                 </a:solidFill>
@@ -4960,11 +4960,11 @@
           <a:p>
             <a:pPr>
               <a:spcAft>
-                <a:spcPts val="150"/>
+                <a:spcPts val="200"/>
               </a:spcAft>
-              <a:defRPr sz="850">
-                <a:solidFill>
-                  <a:srgbClr val="64748B"/>
+              <a:defRPr sz="950">
+                <a:solidFill>
+                  <a:srgbClr val="6E7E96"/>
                 </a:solidFill>
                 <a:latin typeface="Consolas"/>
               </a:defRPr>
@@ -4976,9 +4976,9 @@
           <a:p>
             <a:pPr>
               <a:spcAft>
-                <a:spcPts val="150"/>
+                <a:spcPts val="200"/>
               </a:spcAft>
-              <a:defRPr sz="850">
+              <a:defRPr sz="950">
                 <a:solidFill>
                   <a:srgbClr val="818CF8"/>
                 </a:solidFill>
@@ -4992,9 +4992,9 @@
           <a:p>
             <a:pPr>
               <a:spcAft>
-                <a:spcPts val="150"/>
+                <a:spcPts val="200"/>
               </a:spcAft>
-              <a:defRPr sz="850">
+              <a:defRPr sz="950">
                 <a:solidFill>
                   <a:srgbClr val="00F5A0"/>
                 </a:solidFill>
@@ -5008,9 +5008,9 @@
           <a:p>
             <a:pPr>
               <a:spcAft>
-                <a:spcPts val="150"/>
+                <a:spcPts val="200"/>
               </a:spcAft>
-              <a:defRPr sz="850">
+              <a:defRPr sz="950">
                 <a:solidFill>
                   <a:srgbClr val="00F5A0"/>
                 </a:solidFill>
@@ -5024,9 +5024,9 @@
           <a:p>
             <a:pPr>
               <a:spcAft>
-                <a:spcPts val="150"/>
+                <a:spcPts val="200"/>
               </a:spcAft>
-              <a:defRPr sz="850">
+              <a:defRPr sz="950">
                 <a:solidFill>
                   <a:srgbClr val="F1F5F9"/>
                 </a:solidFill>
@@ -5040,9 +5040,9 @@
           <a:p>
             <a:pPr>
               <a:spcAft>
-                <a:spcPts val="150"/>
+                <a:spcPts val="200"/>
               </a:spcAft>
-              <a:defRPr sz="850">
+              <a:defRPr sz="950">
                 <a:solidFill>
                   <a:srgbClr val="F1F5F9"/>
                 </a:solidFill>
@@ -5056,9 +5056,9 @@
           <a:p>
             <a:pPr>
               <a:spcAft>
-                <a:spcPts val="150"/>
+                <a:spcPts val="200"/>
               </a:spcAft>
-              <a:defRPr sz="850">
+              <a:defRPr sz="950">
                 <a:solidFill>
                   <a:srgbClr val="818CF8"/>
                 </a:solidFill>
@@ -5072,9 +5072,9 @@
           <a:p>
             <a:pPr>
               <a:spcAft>
-                <a:spcPts val="150"/>
+                <a:spcPts val="200"/>
               </a:spcAft>
-              <a:defRPr sz="850">
+              <a:defRPr sz="950">
                 <a:solidFill>
                   <a:srgbClr val="FFFFFF"/>
                 </a:solidFill>
@@ -5095,8 +5095,8 @@
         </p:nvSpPr>
         <p:spPr>
           <a:xfrm>
-            <a:off x="7132320" y="1645920"/>
-            <a:ext cx="4327855" cy="1417320"/>
+            <a:off x="7132320" y="1600200"/>
+            <a:ext cx="4327855" cy="1481328"/>
           </a:xfrm>
           <a:prstGeom prst="roundRect">
             <a:avLst/>
@@ -5140,8 +5140,8 @@
         </p:nvSpPr>
         <p:spPr>
           <a:xfrm>
-            <a:off x="7360920" y="1645920"/>
-            <a:ext cx="1645920" cy="36576"/>
+            <a:off x="7406640" y="1600200"/>
+            <a:ext cx="2011680" cy="41148"/>
           </a:xfrm>
           <a:prstGeom prst="roundRect">
             <a:avLst/>
@@ -5183,8 +5183,8 @@
         </p:nvSpPr>
         <p:spPr>
           <a:xfrm>
-            <a:off x="7360920" y="1828800"/>
-            <a:ext cx="3870655" cy="256032"/>
+            <a:off x="7406640" y="1801368"/>
+            <a:ext cx="3779215" cy="274320"/>
           </a:xfrm>
           <a:prstGeom prst="rect">
             <a:avLst/>
@@ -5198,7 +5198,7 @@
           <a:lstStyle/>
           <a:p>
             <a:pPr>
-              <a:defRPr sz="850" b="1">
+              <a:defRPr sz="900" b="1">
                 <a:solidFill>
                   <a:srgbClr val="38BDF8"/>
                 </a:solidFill>
@@ -5219,8 +5219,8 @@
         </p:nvSpPr>
         <p:spPr>
           <a:xfrm>
-            <a:off x="7360920" y="2084832"/>
-            <a:ext cx="3870655" cy="411480"/>
+            <a:off x="7406640" y="2075688"/>
+            <a:ext cx="3779215" cy="457200"/>
           </a:xfrm>
           <a:prstGeom prst="rect">
             <a:avLst/>
@@ -5234,7 +5234,7 @@
           <a:lstStyle/>
           <a:p>
             <a:pPr>
-              <a:defRPr sz="1300" b="1">
+              <a:defRPr sz="1500" b="1">
                 <a:solidFill>
                   <a:srgbClr val="FFFFFF"/>
                 </a:solidFill>
@@ -5255,8 +5255,8 @@
         </p:nvSpPr>
         <p:spPr>
           <a:xfrm>
-            <a:off x="7360920" y="2496312"/>
-            <a:ext cx="3870655" cy="429768"/>
+            <a:off x="7406640" y="2551176"/>
+            <a:ext cx="3779215" cy="393192"/>
           </a:xfrm>
           <a:prstGeom prst="rect">
             <a:avLst/>
@@ -5271,11 +5271,11 @@
           <a:p>
             <a:pPr>
               <a:spcAft>
-                <a:spcPts val="500"/>
+                <a:spcPts val="400"/>
               </a:spcAft>
-              <a:defRPr sz="1000">
-                <a:solidFill>
-                  <a:srgbClr val="94A3B8"/>
+              <a:defRPr sz="1050">
+                <a:solidFill>
+                  <a:srgbClr val="A0AEC0"/>
                 </a:solidFill>
                 <a:latin typeface="Arial"/>
               </a:defRPr>
@@ -5287,11 +5287,11 @@
           <a:p>
             <a:pPr>
               <a:spcAft>
-                <a:spcPts val="500"/>
+                <a:spcPts val="400"/>
               </a:spcAft>
-              <a:defRPr sz="1000">
-                <a:solidFill>
-                  <a:srgbClr val="94A3B8"/>
+              <a:defRPr sz="1050">
+                <a:solidFill>
+                  <a:srgbClr val="A0AEC0"/>
                 </a:solidFill>
                 <a:latin typeface="Arial"/>
               </a:defRPr>
@@ -5310,8 +5310,8 @@
         </p:nvSpPr>
         <p:spPr>
           <a:xfrm>
-            <a:off x="7132320" y="3218688"/>
-            <a:ext cx="4327855" cy="1417320"/>
+            <a:off x="7132320" y="3236976"/>
+            <a:ext cx="4327855" cy="1481328"/>
           </a:xfrm>
           <a:prstGeom prst="roundRect">
             <a:avLst/>
@@ -5355,8 +5355,8 @@
         </p:nvSpPr>
         <p:spPr>
           <a:xfrm>
-            <a:off x="7360920" y="3218688"/>
-            <a:ext cx="1645920" cy="36576"/>
+            <a:off x="7406640" y="3236976"/>
+            <a:ext cx="2011680" cy="41148"/>
           </a:xfrm>
           <a:prstGeom prst="roundRect">
             <a:avLst/>
@@ -5398,8 +5398,8 @@
         </p:nvSpPr>
         <p:spPr>
           <a:xfrm>
-            <a:off x="7360920" y="3401568"/>
-            <a:ext cx="3870655" cy="256032"/>
+            <a:off x="7406640" y="3438144"/>
+            <a:ext cx="3779215" cy="274320"/>
           </a:xfrm>
           <a:prstGeom prst="rect">
             <a:avLst/>
@@ -5413,7 +5413,7 @@
           <a:lstStyle/>
           <a:p>
             <a:pPr>
-              <a:defRPr sz="850" b="1">
+              <a:defRPr sz="900" b="1">
                 <a:solidFill>
                   <a:srgbClr val="818CF8"/>
                 </a:solidFill>
@@ -5434,8 +5434,8 @@
         </p:nvSpPr>
         <p:spPr>
           <a:xfrm>
-            <a:off x="7360920" y="3657600"/>
-            <a:ext cx="3870655" cy="411480"/>
+            <a:off x="7406640" y="3712464"/>
+            <a:ext cx="3779215" cy="457200"/>
           </a:xfrm>
           <a:prstGeom prst="rect">
             <a:avLst/>
@@ -5449,7 +5449,7 @@
           <a:lstStyle/>
           <a:p>
             <a:pPr>
-              <a:defRPr sz="1300" b="1">
+              <a:defRPr sz="1500" b="1">
                 <a:solidFill>
                   <a:srgbClr val="FFFFFF"/>
                 </a:solidFill>
@@ -5470,8 +5470,8 @@
         </p:nvSpPr>
         <p:spPr>
           <a:xfrm>
-            <a:off x="7360920" y="4069080"/>
-            <a:ext cx="3870655" cy="429768"/>
+            <a:off x="7406640" y="4187952"/>
+            <a:ext cx="3779215" cy="393192"/>
           </a:xfrm>
           <a:prstGeom prst="rect">
             <a:avLst/>
@@ -5486,11 +5486,11 @@
           <a:p>
             <a:pPr>
               <a:spcAft>
-                <a:spcPts val="500"/>
+                <a:spcPts val="400"/>
               </a:spcAft>
-              <a:defRPr sz="1000">
-                <a:solidFill>
-                  <a:srgbClr val="94A3B8"/>
+              <a:defRPr sz="1050">
+                <a:solidFill>
+                  <a:srgbClr val="A0AEC0"/>
                 </a:solidFill>
                 <a:latin typeface="Arial"/>
               </a:defRPr>
@@ -5502,11 +5502,11 @@
           <a:p>
             <a:pPr>
               <a:spcAft>
-                <a:spcPts val="500"/>
+                <a:spcPts val="400"/>
               </a:spcAft>
-              <a:defRPr sz="1000">
-                <a:solidFill>
-                  <a:srgbClr val="94A3B8"/>
+              <a:defRPr sz="1050">
+                <a:solidFill>
+                  <a:srgbClr val="A0AEC0"/>
                 </a:solidFill>
                 <a:latin typeface="Arial"/>
               </a:defRPr>
@@ -5525,8 +5525,8 @@
         </p:nvSpPr>
         <p:spPr>
           <a:xfrm>
-            <a:off x="7132320" y="4800600"/>
-            <a:ext cx="4327855" cy="1417320"/>
+            <a:off x="7132320" y="4873752"/>
+            <a:ext cx="4327855" cy="1481328"/>
           </a:xfrm>
           <a:prstGeom prst="roundRect">
             <a:avLst/>
@@ -5570,8 +5570,8 @@
         </p:nvSpPr>
         <p:spPr>
           <a:xfrm>
-            <a:off x="7360920" y="4800600"/>
-            <a:ext cx="1645920" cy="36576"/>
+            <a:off x="7406640" y="4873752"/>
+            <a:ext cx="2011680" cy="41148"/>
           </a:xfrm>
           <a:prstGeom prst="roundRect">
             <a:avLst/>
@@ -5613,8 +5613,8 @@
         </p:nvSpPr>
         <p:spPr>
           <a:xfrm>
-            <a:off x="7360920" y="4983480"/>
-            <a:ext cx="3870655" cy="256032"/>
+            <a:off x="7406640" y="5074920"/>
+            <a:ext cx="3779215" cy="274320"/>
           </a:xfrm>
           <a:prstGeom prst="rect">
             <a:avLst/>
@@ -5628,7 +5628,7 @@
           <a:lstStyle/>
           <a:p>
             <a:pPr>
-              <a:defRPr sz="850" b="1">
+              <a:defRPr sz="900" b="1">
                 <a:solidFill>
                   <a:srgbClr val="00F5A0"/>
                 </a:solidFill>
@@ -5649,8 +5649,8 @@
         </p:nvSpPr>
         <p:spPr>
           <a:xfrm>
-            <a:off x="7360920" y="5239512"/>
-            <a:ext cx="3870655" cy="411480"/>
+            <a:off x="7406640" y="5349240"/>
+            <a:ext cx="3779215" cy="457200"/>
           </a:xfrm>
           <a:prstGeom prst="rect">
             <a:avLst/>
@@ -5664,7 +5664,7 @@
           <a:lstStyle/>
           <a:p>
             <a:pPr>
-              <a:defRPr sz="1300" b="1">
+              <a:defRPr sz="1500" b="1">
                 <a:solidFill>
                   <a:srgbClr val="FFFFFF"/>
                 </a:solidFill>
@@ -5685,8 +5685,8 @@
         </p:nvSpPr>
         <p:spPr>
           <a:xfrm>
-            <a:off x="7360920" y="5650992"/>
-            <a:ext cx="3870655" cy="429768"/>
+            <a:off x="7406640" y="5824728"/>
+            <a:ext cx="3779215" cy="393192"/>
           </a:xfrm>
           <a:prstGeom prst="rect">
             <a:avLst/>
@@ -5701,11 +5701,11 @@
           <a:p>
             <a:pPr>
               <a:spcAft>
-                <a:spcPts val="500"/>
+                <a:spcPts val="400"/>
               </a:spcAft>
-              <a:defRPr sz="1000">
-                <a:solidFill>
-                  <a:srgbClr val="94A3B8"/>
+              <a:defRPr sz="1050">
+                <a:solidFill>
+                  <a:srgbClr val="A0AEC0"/>
                 </a:solidFill>
                 <a:latin typeface="Arial"/>
               </a:defRPr>
@@ -5717,11 +5717,11 @@
           <a:p>
             <a:pPr>
               <a:spcAft>
-                <a:spcPts val="500"/>
+                <a:spcPts val="400"/>
               </a:spcAft>
-              <a:defRPr sz="1000">
-                <a:solidFill>
-                  <a:srgbClr val="94A3B8"/>
+              <a:defRPr sz="1050">
+                <a:solidFill>
+                  <a:srgbClr val="A0AEC0"/>
                 </a:solidFill>
                 <a:latin typeface="Arial"/>
               </a:defRPr>
@@ -5802,7 +5802,7 @@
         <p:spPr>
           <a:xfrm>
             <a:off x="731520" y="365760"/>
-            <a:ext cx="10698480" cy="292608"/>
+            <a:ext cx="10698480" cy="320040"/>
           </a:xfrm>
           <a:prstGeom prst="rect">
             <a:avLst/>
@@ -5816,7 +5816,7 @@
           <a:lstStyle/>
           <a:p>
             <a:pPr>
-              <a:defRPr sz="950" b="1">
+              <a:defRPr sz="1000" b="1">
                 <a:solidFill>
                   <a:srgbClr val="00F5A0"/>
                 </a:solidFill>
@@ -5838,7 +5838,7 @@
         <p:spPr>
           <a:xfrm>
             <a:off x="731520" y="658368"/>
-            <a:ext cx="10698480" cy="594360"/>
+            <a:ext cx="10698480" cy="640080"/>
           </a:xfrm>
           <a:prstGeom prst="rect">
             <a:avLst/>
@@ -5852,7 +5852,7 @@
           <a:lstStyle/>
           <a:p>
             <a:pPr>
-              <a:defRPr sz="2200" b="1">
+              <a:defRPr sz="2400" b="1">
                 <a:solidFill>
                   <a:srgbClr val="FFFFFF"/>
                 </a:solidFill>
@@ -5873,8 +5873,8 @@
         </p:nvSpPr>
         <p:spPr>
           <a:xfrm>
-            <a:off x="731520" y="1298448"/>
-            <a:ext cx="10728655" cy="13716"/>
+            <a:off x="731520" y="1325880"/>
+            <a:ext cx="10728655" cy="16459"/>
           </a:xfrm>
           <a:prstGeom prst="rect">
             <a:avLst/>
@@ -5916,8 +5916,8 @@
         </p:nvSpPr>
         <p:spPr>
           <a:xfrm>
-            <a:off x="731520" y="1298448"/>
-            <a:ext cx="1097280" cy="22860"/>
+            <a:off x="731520" y="1325880"/>
+            <a:ext cx="1371600" cy="27432"/>
           </a:xfrm>
           <a:prstGeom prst="rect">
             <a:avLst/>
@@ -5959,8 +5959,8 @@
         </p:nvSpPr>
         <p:spPr>
           <a:xfrm>
-            <a:off x="731520" y="1645920"/>
-            <a:ext cx="2542032" cy="4572000"/>
+            <a:off x="731520" y="1600200"/>
+            <a:ext cx="2542032" cy="4754880"/>
           </a:xfrm>
           <a:prstGeom prst="roundRect">
             <a:avLst/>
@@ -6004,8 +6004,8 @@
         </p:nvSpPr>
         <p:spPr>
           <a:xfrm>
-            <a:off x="960120" y="1645920"/>
-            <a:ext cx="1645920" cy="36576"/>
+            <a:off x="1005840" y="1600200"/>
+            <a:ext cx="1993391" cy="41148"/>
           </a:xfrm>
           <a:prstGeom prst="roundRect">
             <a:avLst/>
@@ -6047,8 +6047,8 @@
         </p:nvSpPr>
         <p:spPr>
           <a:xfrm>
-            <a:off x="960120" y="1828800"/>
-            <a:ext cx="2084831" cy="256032"/>
+            <a:off x="1005840" y="1801368"/>
+            <a:ext cx="1993391" cy="274320"/>
           </a:xfrm>
           <a:prstGeom prst="rect">
             <a:avLst/>
@@ -6062,7 +6062,7 @@
           <a:lstStyle/>
           <a:p>
             <a:pPr>
-              <a:defRPr sz="850" b="1">
+              <a:defRPr sz="900" b="1">
                 <a:solidFill>
                   <a:srgbClr val="00F5A0"/>
                 </a:solidFill>
@@ -6083,8 +6083,8 @@
         </p:nvSpPr>
         <p:spPr>
           <a:xfrm>
-            <a:off x="960120" y="2084832"/>
-            <a:ext cx="2084831" cy="411480"/>
+            <a:off x="1005840" y="2075688"/>
+            <a:ext cx="1993391" cy="457200"/>
           </a:xfrm>
           <a:prstGeom prst="rect">
             <a:avLst/>
@@ -6098,7 +6098,7 @@
           <a:lstStyle/>
           <a:p>
             <a:pPr>
-              <a:defRPr sz="1300" b="1">
+              <a:defRPr sz="1500" b="1">
                 <a:solidFill>
                   <a:srgbClr val="FFFFFF"/>
                 </a:solidFill>
@@ -6119,8 +6119,8 @@
         </p:nvSpPr>
         <p:spPr>
           <a:xfrm>
-            <a:off x="960120" y="2496312"/>
-            <a:ext cx="2084831" cy="3584448"/>
+            <a:off x="1005840" y="2551176"/>
+            <a:ext cx="1993391" cy="3666744"/>
           </a:xfrm>
           <a:prstGeom prst="rect">
             <a:avLst/>
@@ -6135,11 +6135,11 @@
           <a:p>
             <a:pPr>
               <a:spcAft>
-                <a:spcPts val="500"/>
+                <a:spcPts val="1000"/>
               </a:spcAft>
-              <a:defRPr sz="1000">
-                <a:solidFill>
-                  <a:srgbClr val="94A3B8"/>
+              <a:defRPr sz="1150">
+                <a:solidFill>
+                  <a:srgbClr val="A0AEC0"/>
                 </a:solidFill>
                 <a:latin typeface="Arial"/>
               </a:defRPr>
@@ -6151,11 +6151,11 @@
           <a:p>
             <a:pPr>
               <a:spcAft>
-                <a:spcPts val="500"/>
+                <a:spcPts val="1000"/>
               </a:spcAft>
-              <a:defRPr sz="1000">
-                <a:solidFill>
-                  <a:srgbClr val="94A3B8"/>
+              <a:defRPr sz="1150">
+                <a:solidFill>
+                  <a:srgbClr val="A0AEC0"/>
                 </a:solidFill>
                 <a:latin typeface="Arial"/>
               </a:defRPr>
@@ -6174,8 +6174,8 @@
         </p:nvSpPr>
         <p:spPr>
           <a:xfrm>
-            <a:off x="3456432" y="1645920"/>
-            <a:ext cx="2542032" cy="4572000"/>
+            <a:off x="3456432" y="1600200"/>
+            <a:ext cx="2542032" cy="4754880"/>
           </a:xfrm>
           <a:prstGeom prst="roundRect">
             <a:avLst/>
@@ -6219,8 +6219,8 @@
         </p:nvSpPr>
         <p:spPr>
           <a:xfrm>
-            <a:off x="3685032" y="1645920"/>
-            <a:ext cx="1645920" cy="36576"/>
+            <a:off x="3730752" y="1600200"/>
+            <a:ext cx="1993391" cy="41148"/>
           </a:xfrm>
           <a:prstGeom prst="roundRect">
             <a:avLst/>
@@ -6262,8 +6262,8 @@
         </p:nvSpPr>
         <p:spPr>
           <a:xfrm>
-            <a:off x="3685032" y="1828800"/>
-            <a:ext cx="2084831" cy="256032"/>
+            <a:off x="3730752" y="1801368"/>
+            <a:ext cx="1993391" cy="274320"/>
           </a:xfrm>
           <a:prstGeom prst="rect">
             <a:avLst/>
@@ -6277,7 +6277,7 @@
           <a:lstStyle/>
           <a:p>
             <a:pPr>
-              <a:defRPr sz="850" b="1">
+              <a:defRPr sz="900" b="1">
                 <a:solidFill>
                   <a:srgbClr val="818CF8"/>
                 </a:solidFill>
@@ -6298,8 +6298,8 @@
         </p:nvSpPr>
         <p:spPr>
           <a:xfrm>
-            <a:off x="3685032" y="2084832"/>
-            <a:ext cx="2084831" cy="411480"/>
+            <a:off x="3730752" y="2075688"/>
+            <a:ext cx="1993391" cy="457200"/>
           </a:xfrm>
           <a:prstGeom prst="rect">
             <a:avLst/>
@@ -6313,7 +6313,7 @@
           <a:lstStyle/>
           <a:p>
             <a:pPr>
-              <a:defRPr sz="1300" b="1">
+              <a:defRPr sz="1500" b="1">
                 <a:solidFill>
                   <a:srgbClr val="FFFFFF"/>
                 </a:solidFill>
@@ -6334,8 +6334,8 @@
         </p:nvSpPr>
         <p:spPr>
           <a:xfrm>
-            <a:off x="3685032" y="2496312"/>
-            <a:ext cx="2084831" cy="3584448"/>
+            <a:off x="3730752" y="2551176"/>
+            <a:ext cx="1993391" cy="3666744"/>
           </a:xfrm>
           <a:prstGeom prst="rect">
             <a:avLst/>
@@ -6350,11 +6350,11 @@
           <a:p>
             <a:pPr>
               <a:spcAft>
-                <a:spcPts val="500"/>
+                <a:spcPts val="1000"/>
               </a:spcAft>
-              <a:defRPr sz="1000">
-                <a:solidFill>
-                  <a:srgbClr val="94A3B8"/>
+              <a:defRPr sz="1150">
+                <a:solidFill>
+                  <a:srgbClr val="A0AEC0"/>
                 </a:solidFill>
                 <a:latin typeface="Arial"/>
               </a:defRPr>
@@ -6366,11 +6366,11 @@
           <a:p>
             <a:pPr>
               <a:spcAft>
-                <a:spcPts val="500"/>
+                <a:spcPts val="1000"/>
               </a:spcAft>
-              <a:defRPr sz="1000">
-                <a:solidFill>
-                  <a:srgbClr val="94A3B8"/>
+              <a:defRPr sz="1150">
+                <a:solidFill>
+                  <a:srgbClr val="A0AEC0"/>
                 </a:solidFill>
                 <a:latin typeface="Arial"/>
               </a:defRPr>
@@ -6389,8 +6389,8 @@
         </p:nvSpPr>
         <p:spPr>
           <a:xfrm>
-            <a:off x="6181344" y="1645920"/>
-            <a:ext cx="2542032" cy="4572000"/>
+            <a:off x="6181344" y="1600200"/>
+            <a:ext cx="2542032" cy="4754880"/>
           </a:xfrm>
           <a:prstGeom prst="roundRect">
             <a:avLst/>
@@ -6434,8 +6434,8 @@
         </p:nvSpPr>
         <p:spPr>
           <a:xfrm>
-            <a:off x="6409944" y="1645920"/>
-            <a:ext cx="1645920" cy="36576"/>
+            <a:off x="6455664" y="1600200"/>
+            <a:ext cx="1993391" cy="41148"/>
           </a:xfrm>
           <a:prstGeom prst="roundRect">
             <a:avLst/>
@@ -6477,8 +6477,8 @@
         </p:nvSpPr>
         <p:spPr>
           <a:xfrm>
-            <a:off x="6409944" y="1828800"/>
-            <a:ext cx="2084831" cy="256032"/>
+            <a:off x="6455664" y="1801368"/>
+            <a:ext cx="1993391" cy="274320"/>
           </a:xfrm>
           <a:prstGeom prst="rect">
             <a:avLst/>
@@ -6492,7 +6492,7 @@
           <a:lstStyle/>
           <a:p>
             <a:pPr>
-              <a:defRPr sz="850" b="1">
+              <a:defRPr sz="900" b="1">
                 <a:solidFill>
                   <a:srgbClr val="38BDF8"/>
                 </a:solidFill>
@@ -6513,8 +6513,8 @@
         </p:nvSpPr>
         <p:spPr>
           <a:xfrm>
-            <a:off x="6409944" y="2084832"/>
-            <a:ext cx="2084831" cy="411480"/>
+            <a:off x="6455664" y="2075688"/>
+            <a:ext cx="1993391" cy="457200"/>
           </a:xfrm>
           <a:prstGeom prst="rect">
             <a:avLst/>
@@ -6528,7 +6528,7 @@
           <a:lstStyle/>
           <a:p>
             <a:pPr>
-              <a:defRPr sz="1300" b="1">
+              <a:defRPr sz="1500" b="1">
                 <a:solidFill>
                   <a:srgbClr val="FFFFFF"/>
                 </a:solidFill>
@@ -6549,8 +6549,8 @@
         </p:nvSpPr>
         <p:spPr>
           <a:xfrm>
-            <a:off x="6409944" y="2496312"/>
-            <a:ext cx="2084831" cy="3584448"/>
+            <a:off x="6455664" y="2551176"/>
+            <a:ext cx="1993391" cy="3666744"/>
           </a:xfrm>
           <a:prstGeom prst="rect">
             <a:avLst/>
@@ -6565,11 +6565,11 @@
           <a:p>
             <a:pPr>
               <a:spcAft>
-                <a:spcPts val="500"/>
+                <a:spcPts val="1000"/>
               </a:spcAft>
-              <a:defRPr sz="1000">
-                <a:solidFill>
-                  <a:srgbClr val="94A3B8"/>
+              <a:defRPr sz="1150">
+                <a:solidFill>
+                  <a:srgbClr val="A0AEC0"/>
                 </a:solidFill>
                 <a:latin typeface="Arial"/>
               </a:defRPr>
@@ -6581,11 +6581,11 @@
           <a:p>
             <a:pPr>
               <a:spcAft>
-                <a:spcPts val="500"/>
+                <a:spcPts val="1000"/>
               </a:spcAft>
-              <a:defRPr sz="1000">
-                <a:solidFill>
-                  <a:srgbClr val="94A3B8"/>
+              <a:defRPr sz="1150">
+                <a:solidFill>
+                  <a:srgbClr val="A0AEC0"/>
                 </a:solidFill>
                 <a:latin typeface="Arial"/>
               </a:defRPr>
@@ -6604,8 +6604,8 @@
         </p:nvSpPr>
         <p:spPr>
           <a:xfrm>
-            <a:off x="8906256" y="1645920"/>
-            <a:ext cx="2542032" cy="4572000"/>
+            <a:off x="8906256" y="1600200"/>
+            <a:ext cx="2542032" cy="4754880"/>
           </a:xfrm>
           <a:prstGeom prst="roundRect">
             <a:avLst/>
@@ -6649,8 +6649,8 @@
         </p:nvSpPr>
         <p:spPr>
           <a:xfrm>
-            <a:off x="9134856" y="1645920"/>
-            <a:ext cx="1645920" cy="36576"/>
+            <a:off x="9180576" y="1600200"/>
+            <a:ext cx="1993391" cy="41148"/>
           </a:xfrm>
           <a:prstGeom prst="roundRect">
             <a:avLst/>
@@ -6692,8 +6692,8 @@
         </p:nvSpPr>
         <p:spPr>
           <a:xfrm>
-            <a:off x="9134856" y="1828800"/>
-            <a:ext cx="2084831" cy="256032"/>
+            <a:off x="9180576" y="1801368"/>
+            <a:ext cx="1993391" cy="274320"/>
           </a:xfrm>
           <a:prstGeom prst="rect">
             <a:avLst/>
@@ -6707,7 +6707,7 @@
           <a:lstStyle/>
           <a:p>
             <a:pPr>
-              <a:defRPr sz="850" b="1">
+              <a:defRPr sz="900" b="1">
                 <a:solidFill>
                   <a:srgbClr val="10B981"/>
                 </a:solidFill>
@@ -6728,8 +6728,8 @@
         </p:nvSpPr>
         <p:spPr>
           <a:xfrm>
-            <a:off x="9134856" y="2084832"/>
-            <a:ext cx="2084831" cy="411480"/>
+            <a:off x="9180576" y="2075688"/>
+            <a:ext cx="1993391" cy="457200"/>
           </a:xfrm>
           <a:prstGeom prst="rect">
             <a:avLst/>
@@ -6743,7 +6743,7 @@
           <a:lstStyle/>
           <a:p>
             <a:pPr>
-              <a:defRPr sz="1300" b="1">
+              <a:defRPr sz="1500" b="1">
                 <a:solidFill>
                   <a:srgbClr val="FFFFFF"/>
                 </a:solidFill>
@@ -6764,8 +6764,8 @@
         </p:nvSpPr>
         <p:spPr>
           <a:xfrm>
-            <a:off x="9134856" y="2496312"/>
-            <a:ext cx="2084831" cy="3584448"/>
+            <a:off x="9180576" y="2551176"/>
+            <a:ext cx="1993391" cy="3666744"/>
           </a:xfrm>
           <a:prstGeom prst="rect">
             <a:avLst/>
@@ -6780,11 +6780,11 @@
           <a:p>
             <a:pPr>
               <a:spcAft>
-                <a:spcPts val="500"/>
+                <a:spcPts val="1000"/>
               </a:spcAft>
-              <a:defRPr sz="1000">
-                <a:solidFill>
-                  <a:srgbClr val="94A3B8"/>
+              <a:defRPr sz="1150">
+                <a:solidFill>
+                  <a:srgbClr val="A0AEC0"/>
                 </a:solidFill>
                 <a:latin typeface="Arial"/>
               </a:defRPr>
@@ -6796,11 +6796,11 @@
           <a:p>
             <a:pPr>
               <a:spcAft>
-                <a:spcPts val="500"/>
+                <a:spcPts val="1000"/>
               </a:spcAft>
-              <a:defRPr sz="1000">
-                <a:solidFill>
-                  <a:srgbClr val="94A3B8"/>
+              <a:defRPr sz="1150">
+                <a:solidFill>
+                  <a:srgbClr val="A0AEC0"/>
                 </a:solidFill>
                 <a:latin typeface="Arial"/>
               </a:defRPr>
@@ -6881,7 +6881,7 @@
         <p:spPr>
           <a:xfrm>
             <a:off x="731520" y="365760"/>
-            <a:ext cx="10698480" cy="292608"/>
+            <a:ext cx="10698480" cy="320040"/>
           </a:xfrm>
           <a:prstGeom prst="rect">
             <a:avLst/>
@@ -6895,7 +6895,7 @@
           <a:lstStyle/>
           <a:p>
             <a:pPr>
-              <a:defRPr sz="950" b="1">
+              <a:defRPr sz="1000" b="1">
                 <a:solidFill>
                   <a:srgbClr val="00F5A0"/>
                 </a:solidFill>
@@ -6917,7 +6917,7 @@
         <p:spPr>
           <a:xfrm>
             <a:off x="731520" y="658368"/>
-            <a:ext cx="10698480" cy="594360"/>
+            <a:ext cx="10698480" cy="640080"/>
           </a:xfrm>
           <a:prstGeom prst="rect">
             <a:avLst/>
@@ -6931,7 +6931,7 @@
           <a:lstStyle/>
           <a:p>
             <a:pPr>
-              <a:defRPr sz="2200" b="1">
+              <a:defRPr sz="2400" b="1">
                 <a:solidFill>
                   <a:srgbClr val="FFFFFF"/>
                 </a:solidFill>
@@ -6952,8 +6952,8 @@
         </p:nvSpPr>
         <p:spPr>
           <a:xfrm>
-            <a:off x="731520" y="1298448"/>
-            <a:ext cx="10728655" cy="13716"/>
+            <a:off x="731520" y="1325880"/>
+            <a:ext cx="10728655" cy="16459"/>
           </a:xfrm>
           <a:prstGeom prst="rect">
             <a:avLst/>
@@ -6995,8 +6995,8 @@
         </p:nvSpPr>
         <p:spPr>
           <a:xfrm>
-            <a:off x="731520" y="1298448"/>
-            <a:ext cx="1097280" cy="22860"/>
+            <a:off x="731520" y="1325880"/>
+            <a:ext cx="1371600" cy="27432"/>
           </a:xfrm>
           <a:prstGeom prst="rect">
             <a:avLst/>
@@ -7038,8 +7038,8 @@
         </p:nvSpPr>
         <p:spPr>
           <a:xfrm>
-            <a:off x="731520" y="1645920"/>
-            <a:ext cx="10728655" cy="4572000"/>
+            <a:off x="731520" y="1600200"/>
+            <a:ext cx="10728655" cy="4754880"/>
           </a:xfrm>
           <a:prstGeom prst="roundRect">
             <a:avLst/>
@@ -7083,7 +7083,7 @@
         </p:nvSpPr>
         <p:spPr>
           <a:xfrm>
-            <a:off x="1005840" y="1828800"/>
+            <a:off x="1005840" y="1783080"/>
             <a:ext cx="10149840" cy="365760"/>
           </a:xfrm>
           <a:prstGeom prst="rect">
@@ -7098,7 +7098,7 @@
           <a:lstStyle/>
           <a:p>
             <a:pPr>
-              <a:defRPr sz="1000" b="1">
+              <a:defRPr sz="1100" b="1">
                 <a:solidFill>
                   <a:srgbClr val="00F5A0"/>
                 </a:solidFill>
@@ -7106,7 +7106,7 @@
               </a:defRPr>
             </a:pPr>
             <a:r>
-              <a:t>FEATURE / CAPABILITY                TRADITIONAL PUBLIC VAULT            KNIGHT.VAULT (MIDNIGHT)</a:t>
+              <a:t>FEATURE / CAPABILITY             TRADITIONAL PUBLIC VAULT           KNIGHT.VAULT (MIDNIGHT)</a:t>
             </a:r>
           </a:p>
         </p:txBody>
@@ -7163,7 +7163,7 @@
         <p:spPr>
           <a:xfrm>
             <a:off x="1005840" y="2423160"/>
-            <a:ext cx="10149840" cy="566928"/>
+            <a:ext cx="10149840" cy="621792"/>
           </a:xfrm>
           <a:prstGeom prst="roundRect">
             <a:avLst/>
@@ -7207,8 +7207,8 @@
         </p:nvSpPr>
         <p:spPr>
           <a:xfrm>
-            <a:off x="1143000" y="2532888"/>
-            <a:ext cx="9875520" cy="365760"/>
+            <a:off x="1143000" y="2551176"/>
+            <a:ext cx="9875520" cy="411480"/>
           </a:xfrm>
           <a:prstGeom prst="rect">
             <a:avLst/>
@@ -7222,7 +7222,7 @@
           <a:lstStyle/>
           <a:p>
             <a:pPr>
-              <a:defRPr sz="950">
+              <a:defRPr sz="1000">
                 <a:solidFill>
                   <a:srgbClr val="F1F5F9"/>
                 </a:solidFill>
@@ -7230,7 +7230,7 @@
               </a:defRPr>
             </a:pPr>
             <a:r>
-              <a:t>• Owner Identity Visibility      | Publicly linkable to wallet address | ✓ Shielded via private ZK witness key</a:t>
+              <a:t>• Owner Identity Visibility    | Publicly linkable to wallet address | ✓ Shielded via private ZK witness key</a:t>
             </a:r>
           </a:p>
         </p:txBody>
@@ -7243,8 +7243,8 @@
         </p:nvSpPr>
         <p:spPr>
           <a:xfrm>
-            <a:off x="1005840" y="3108960"/>
-            <a:ext cx="10149840" cy="566928"/>
+            <a:off x="1005840" y="3154680"/>
+            <a:ext cx="10149840" cy="621792"/>
           </a:xfrm>
           <a:prstGeom prst="roundRect">
             <a:avLst/>
@@ -7288,8 +7288,8 @@
         </p:nvSpPr>
         <p:spPr>
           <a:xfrm>
-            <a:off x="1143000" y="3218688"/>
-            <a:ext cx="9875520" cy="365760"/>
+            <a:off x="1143000" y="3282696"/>
+            <a:ext cx="9875520" cy="411480"/>
           </a:xfrm>
           <a:prstGeom prst="rect">
             <a:avLst/>
@@ -7303,7 +7303,7 @@
           <a:lstStyle/>
           <a:p>
             <a:pPr>
-              <a:defRPr sz="950">
+              <a:defRPr sz="1000">
                 <a:solidFill>
                   <a:srgbClr val="F1F5F9"/>
                 </a:solidFill>
@@ -7311,7 +7311,7 @@
               </a:defRPr>
             </a:pPr>
             <a:r>
-              <a:t>• Payer Friction                 | Requires native gas token in every wallet | ✓ Zero-gas sponsored checkout flow</a:t>
+              <a:t>• Payer Friction               | Requires native gas token in every wallet | ✓ Zero-gas sponsored checkout flow</a:t>
             </a:r>
           </a:p>
         </p:txBody>
@@ -7324,8 +7324,8 @@
         </p:nvSpPr>
         <p:spPr>
           <a:xfrm>
-            <a:off x="1005840" y="3794760"/>
-            <a:ext cx="10149840" cy="566928"/>
+            <a:off x="1005840" y="3886200"/>
+            <a:ext cx="10149840" cy="621792"/>
           </a:xfrm>
           <a:prstGeom prst="roundRect">
             <a:avLst/>
@@ -7369,8 +7369,8 @@
         </p:nvSpPr>
         <p:spPr>
           <a:xfrm>
-            <a:off x="1143000" y="3904488"/>
-            <a:ext cx="9875520" cy="365760"/>
+            <a:off x="1143000" y="4014215"/>
+            <a:ext cx="9875520" cy="411480"/>
           </a:xfrm>
           <a:prstGeom prst="rect">
             <a:avLst/>
@@ -7384,7 +7384,7 @@
           <a:lstStyle/>
           <a:p>
             <a:pPr>
-              <a:defRPr sz="950">
+              <a:defRPr sz="1000">
                 <a:solidFill>
                   <a:srgbClr val="F1F5F9"/>
                 </a:solidFill>
@@ -7392,7 +7392,7 @@
               </a:defRPr>
             </a:pPr>
             <a:r>
-              <a:t>• Auditability &amp; Compliance      | Scrapes block explorer (zero privacy) | ✓ Selective cryptographic QR receipts</a:t>
+              <a:t>• Auditability &amp; Compliance    | Scrapes block explorer (zero privacy) | ✓ Selective cryptographic QR receipts</a:t>
             </a:r>
           </a:p>
         </p:txBody>
@@ -7405,8 +7405,8 @@
         </p:nvSpPr>
         <p:spPr>
           <a:xfrm>
-            <a:off x="1005840" y="4480560"/>
-            <a:ext cx="10149840" cy="566928"/>
+            <a:off x="1005840" y="4617720"/>
+            <a:ext cx="10149840" cy="621792"/>
           </a:xfrm>
           <a:prstGeom prst="roundRect">
             <a:avLst/>
@@ -7450,8 +7450,8 @@
         </p:nvSpPr>
         <p:spPr>
           <a:xfrm>
-            <a:off x="1143000" y="4590288"/>
-            <a:ext cx="9875520" cy="365760"/>
+            <a:off x="1143000" y="4745736"/>
+            <a:ext cx="9875520" cy="411480"/>
           </a:xfrm>
           <a:prstGeom prst="rect">
             <a:avLst/>
@@ -7465,7 +7465,7 @@
           <a:lstStyle/>
           <a:p>
             <a:pPr>
-              <a:defRPr sz="950">
+              <a:defRPr sz="1000">
                 <a:solidFill>
                   <a:srgbClr val="F1F5F9"/>
                 </a:solidFill>
@@ -7473,7 +7473,7 @@
               </a:defRPr>
             </a:pPr>
             <a:r>
-              <a:t>• Smart Contract Engine          | EVM Bytecode (Transparent Execution) | ✓ Compact v0.20+ (ZK Circuit Compilation)</a:t>
+              <a:t>• Smart Contract Engine        | EVM Bytecode (Transparent Execution) | ✓ Compact Circuits (ZK Proof Compilation)</a:t>
             </a:r>
           </a:p>
         </p:txBody>
@@ -7486,8 +7486,8 @@
         </p:nvSpPr>
         <p:spPr>
           <a:xfrm>
-            <a:off x="1005840" y="5166360"/>
-            <a:ext cx="10149840" cy="566928"/>
+            <a:off x="1005840" y="5349240"/>
+            <a:ext cx="10149840" cy="621792"/>
           </a:xfrm>
           <a:prstGeom prst="roundRect">
             <a:avLst/>
@@ -7531,8 +7531,8 @@
         </p:nvSpPr>
         <p:spPr>
           <a:xfrm>
-            <a:off x="1143000" y="5276088"/>
-            <a:ext cx="9875520" cy="365760"/>
+            <a:off x="1143000" y="5477255"/>
+            <a:ext cx="9875520" cy="411480"/>
           </a:xfrm>
           <a:prstGeom prst="rect">
             <a:avLst/>
@@ -7546,7 +7546,7 @@
           <a:lstStyle/>
           <a:p>
             <a:pPr>
-              <a:defRPr sz="950">
+              <a:defRPr sz="1000">
                 <a:solidFill>
                   <a:srgbClr val="F1F5F9"/>
                 </a:solidFill>
@@ -7554,7 +7554,7 @@
               </a:defRPr>
             </a:pPr>
             <a:r>
-              <a:t>• Proving Architecture           | N/A (No Client Proving)            | ✓ 100% Local ProofStation (Docker :6300)</a:t>
+              <a:t>• Proving Architecture         | N/A (No Client Proving)           | ✓ 100% Local ProofStation (Docker :6300)</a:t>
             </a:r>
           </a:p>
         </p:txBody>
@@ -7629,7 +7629,7 @@
         <p:spPr>
           <a:xfrm>
             <a:off x="731520" y="365760"/>
-            <a:ext cx="10698480" cy="292608"/>
+            <a:ext cx="10698480" cy="320040"/>
           </a:xfrm>
           <a:prstGeom prst="rect">
             <a:avLst/>
@@ -7643,7 +7643,7 @@
           <a:lstStyle/>
           <a:p>
             <a:pPr>
-              <a:defRPr sz="950" b="1">
+              <a:defRPr sz="1000" b="1">
                 <a:solidFill>
                   <a:srgbClr val="00F5A0"/>
                 </a:solidFill>
@@ -7665,7 +7665,7 @@
         <p:spPr>
           <a:xfrm>
             <a:off x="731520" y="658368"/>
-            <a:ext cx="10698480" cy="594360"/>
+            <a:ext cx="10698480" cy="640080"/>
           </a:xfrm>
           <a:prstGeom prst="rect">
             <a:avLst/>
@@ -7679,7 +7679,7 @@
           <a:lstStyle/>
           <a:p>
             <a:pPr>
-              <a:defRPr sz="2200" b="1">
+              <a:defRPr sz="2400" b="1">
                 <a:solidFill>
                   <a:srgbClr val="FFFFFF"/>
                 </a:solidFill>
@@ -7700,8 +7700,8 @@
         </p:nvSpPr>
         <p:spPr>
           <a:xfrm>
-            <a:off x="731520" y="1298448"/>
-            <a:ext cx="10728655" cy="13716"/>
+            <a:off x="731520" y="1325880"/>
+            <a:ext cx="10728655" cy="16459"/>
           </a:xfrm>
           <a:prstGeom prst="rect">
             <a:avLst/>
@@ -7743,8 +7743,8 @@
         </p:nvSpPr>
         <p:spPr>
           <a:xfrm>
-            <a:off x="731520" y="1298448"/>
-            <a:ext cx="1097280" cy="22860"/>
+            <a:off x="731520" y="1325880"/>
+            <a:ext cx="1371600" cy="27432"/>
           </a:xfrm>
           <a:prstGeom prst="rect">
             <a:avLst/>
@@ -7786,8 +7786,8 @@
         </p:nvSpPr>
         <p:spPr>
           <a:xfrm>
-            <a:off x="731520" y="1645920"/>
-            <a:ext cx="3429000" cy="2926080"/>
+            <a:off x="731520" y="1600200"/>
+            <a:ext cx="3429000" cy="3108960"/>
           </a:xfrm>
           <a:prstGeom prst="roundRect">
             <a:avLst/>
@@ -7831,8 +7831,8 @@
         </p:nvSpPr>
         <p:spPr>
           <a:xfrm>
-            <a:off x="960120" y="1645920"/>
-            <a:ext cx="1645920" cy="36576"/>
+            <a:off x="1005840" y="1600200"/>
+            <a:ext cx="2011680" cy="41148"/>
           </a:xfrm>
           <a:prstGeom prst="roundRect">
             <a:avLst/>
@@ -7874,8 +7874,8 @@
         </p:nvSpPr>
         <p:spPr>
           <a:xfrm>
-            <a:off x="960120" y="1828800"/>
-            <a:ext cx="2971800" cy="256032"/>
+            <a:off x="1005840" y="1801368"/>
+            <a:ext cx="2880360" cy="274320"/>
           </a:xfrm>
           <a:prstGeom prst="rect">
             <a:avLst/>
@@ -7889,7 +7889,7 @@
           <a:lstStyle/>
           <a:p>
             <a:pPr>
-              <a:defRPr sz="850" b="1">
+              <a:defRPr sz="900" b="1">
                 <a:solidFill>
                   <a:srgbClr val="00F5A0"/>
                 </a:solidFill>
@@ -7910,8 +7910,8 @@
         </p:nvSpPr>
         <p:spPr>
           <a:xfrm>
-            <a:off x="960120" y="2084832"/>
-            <a:ext cx="2971800" cy="411480"/>
+            <a:off x="1005840" y="2075688"/>
+            <a:ext cx="2880360" cy="457200"/>
           </a:xfrm>
           <a:prstGeom prst="rect">
             <a:avLst/>
@@ -7925,7 +7925,7 @@
           <a:lstStyle/>
           <a:p>
             <a:pPr>
-              <a:defRPr sz="1300" b="1">
+              <a:defRPr sz="1500" b="1">
                 <a:solidFill>
                   <a:srgbClr val="FFFFFF"/>
                 </a:solidFill>
@@ -7946,8 +7946,8 @@
         </p:nvSpPr>
         <p:spPr>
           <a:xfrm>
-            <a:off x="960120" y="2496312"/>
-            <a:ext cx="2971800" cy="1938528"/>
+            <a:off x="1005840" y="2551176"/>
+            <a:ext cx="2880360" cy="2020824"/>
           </a:xfrm>
           <a:prstGeom prst="rect">
             <a:avLst/>
@@ -7962,11 +7962,11 @@
           <a:p>
             <a:pPr>
               <a:spcAft>
-                <a:spcPts val="500"/>
+                <a:spcPts val="800"/>
               </a:spcAft>
-              <a:defRPr sz="1000">
-                <a:solidFill>
-                  <a:srgbClr val="94A3B8"/>
+              <a:defRPr sz="1150">
+                <a:solidFill>
+                  <a:srgbClr val="A0AEC0"/>
                 </a:solidFill>
                 <a:latin typeface="Arial"/>
               </a:defRPr>
@@ -7978,27 +7978,27 @@
           <a:p>
             <a:pPr>
               <a:spcAft>
-                <a:spcPts val="500"/>
+                <a:spcPts val="800"/>
               </a:spcAft>
-              <a:defRPr sz="1000">
-                <a:solidFill>
-                  <a:srgbClr val="94A3B8"/>
+              <a:defRPr sz="1150">
+                <a:solidFill>
+                  <a:srgbClr val="A0AEC0"/>
                 </a:solidFill>
                 <a:latin typeface="Arial"/>
               </a:defRPr>
             </a:pPr>
             <a:r>
-              <a:t>•  Compact v0.20 contract deployed on Preprod.</a:t>
+              <a:t>•  Compact smart contracts on Preprod.</a:t>
             </a:r>
           </a:p>
           <a:p>
             <a:pPr>
               <a:spcAft>
-                <a:spcPts val="500"/>
+                <a:spcPts val="800"/>
               </a:spcAft>
-              <a:defRPr sz="1000">
-                <a:solidFill>
-                  <a:srgbClr val="94A3B8"/>
+              <a:defRPr sz="1150">
+                <a:solidFill>
+                  <a:srgbClr val="A0AEC0"/>
                 </a:solidFill>
                 <a:latin typeface="Arial"/>
               </a:defRPr>
@@ -8010,11 +8010,11 @@
           <a:p>
             <a:pPr>
               <a:spcAft>
-                <a:spcPts val="500"/>
+                <a:spcPts val="800"/>
               </a:spcAft>
-              <a:defRPr sz="1000">
-                <a:solidFill>
-                  <a:srgbClr val="94A3B8"/>
+              <a:defRPr sz="1150">
+                <a:solidFill>
+                  <a:srgbClr val="A0AEC0"/>
                 </a:solidFill>
                 <a:latin typeface="Arial"/>
               </a:defRPr>
@@ -8033,8 +8033,8 @@
         </p:nvSpPr>
         <p:spPr>
           <a:xfrm>
-            <a:off x="4370832" y="1645920"/>
-            <a:ext cx="3429000" cy="2926080"/>
+            <a:off x="4370832" y="1600200"/>
+            <a:ext cx="3429000" cy="3108960"/>
           </a:xfrm>
           <a:prstGeom prst="roundRect">
             <a:avLst/>
@@ -8078,8 +8078,8 @@
         </p:nvSpPr>
         <p:spPr>
           <a:xfrm>
-            <a:off x="4599432" y="1645920"/>
-            <a:ext cx="1645920" cy="36576"/>
+            <a:off x="4645152" y="1600200"/>
+            <a:ext cx="2011680" cy="41148"/>
           </a:xfrm>
           <a:prstGeom prst="roundRect">
             <a:avLst/>
@@ -8121,8 +8121,8 @@
         </p:nvSpPr>
         <p:spPr>
           <a:xfrm>
-            <a:off x="4599432" y="1828800"/>
-            <a:ext cx="2971800" cy="256032"/>
+            <a:off x="4645152" y="1801368"/>
+            <a:ext cx="2880360" cy="274320"/>
           </a:xfrm>
           <a:prstGeom prst="rect">
             <a:avLst/>
@@ -8136,7 +8136,7 @@
           <a:lstStyle/>
           <a:p>
             <a:pPr>
-              <a:defRPr sz="850" b="1">
+              <a:defRPr sz="900" b="1">
                 <a:solidFill>
                   <a:srgbClr val="818CF8"/>
                 </a:solidFill>
@@ -8157,8 +8157,8 @@
         </p:nvSpPr>
         <p:spPr>
           <a:xfrm>
-            <a:off x="4599432" y="2084832"/>
-            <a:ext cx="2971800" cy="411480"/>
+            <a:off x="4645152" y="2075688"/>
+            <a:ext cx="2880360" cy="457200"/>
           </a:xfrm>
           <a:prstGeom prst="rect">
             <a:avLst/>
@@ -8172,7 +8172,7 @@
           <a:lstStyle/>
           <a:p>
             <a:pPr>
-              <a:defRPr sz="1300" b="1">
+              <a:defRPr sz="1500" b="1">
                 <a:solidFill>
                   <a:srgbClr val="FFFFFF"/>
                 </a:solidFill>
@@ -8193,8 +8193,8 @@
         </p:nvSpPr>
         <p:spPr>
           <a:xfrm>
-            <a:off x="4599432" y="2496312"/>
-            <a:ext cx="2971800" cy="1938528"/>
+            <a:off x="4645152" y="2551176"/>
+            <a:ext cx="2880360" cy="2020824"/>
           </a:xfrm>
           <a:prstGeom prst="rect">
             <a:avLst/>
@@ -8209,11 +8209,11 @@
           <a:p>
             <a:pPr>
               <a:spcAft>
-                <a:spcPts val="500"/>
+                <a:spcPts val="800"/>
               </a:spcAft>
-              <a:defRPr sz="1000">
-                <a:solidFill>
-                  <a:srgbClr val="94A3B8"/>
+              <a:defRPr sz="1150">
+                <a:solidFill>
+                  <a:srgbClr val="A0AEC0"/>
                 </a:solidFill>
                 <a:latin typeface="Arial"/>
               </a:defRPr>
@@ -8225,11 +8225,11 @@
           <a:p>
             <a:pPr>
               <a:spcAft>
-                <a:spcPts val="500"/>
+                <a:spcPts val="800"/>
               </a:spcAft>
-              <a:defRPr sz="1000">
-                <a:solidFill>
-                  <a:srgbClr val="94A3B8"/>
+              <a:defRPr sz="1150">
+                <a:solidFill>
+                  <a:srgbClr val="A0AEC0"/>
                 </a:solidFill>
                 <a:latin typeface="Arial"/>
               </a:defRPr>
@@ -8241,11 +8241,11 @@
           <a:p>
             <a:pPr>
               <a:spcAft>
-                <a:spcPts val="500"/>
+                <a:spcPts val="800"/>
               </a:spcAft>
-              <a:defRPr sz="1000">
-                <a:solidFill>
-                  <a:srgbClr val="94A3B8"/>
+              <a:defRPr sz="1150">
+                <a:solidFill>
+                  <a:srgbClr val="A0AEC0"/>
                 </a:solidFill>
                 <a:latin typeface="Arial"/>
               </a:defRPr>
@@ -8257,11 +8257,11 @@
           <a:p>
             <a:pPr>
               <a:spcAft>
-                <a:spcPts val="500"/>
+                <a:spcPts val="800"/>
               </a:spcAft>
-              <a:defRPr sz="1000">
-                <a:solidFill>
-                  <a:srgbClr val="94A3B8"/>
+              <a:defRPr sz="1150">
+                <a:solidFill>
+                  <a:srgbClr val="A0AEC0"/>
                 </a:solidFill>
                 <a:latin typeface="Arial"/>
               </a:defRPr>
@@ -8280,8 +8280,8 @@
         </p:nvSpPr>
         <p:spPr>
           <a:xfrm>
-            <a:off x="8028431" y="1645920"/>
-            <a:ext cx="3429000" cy="2926080"/>
+            <a:off x="8028431" y="1600200"/>
+            <a:ext cx="3429000" cy="3108960"/>
           </a:xfrm>
           <a:prstGeom prst="roundRect">
             <a:avLst/>
@@ -8325,8 +8325,8 @@
         </p:nvSpPr>
         <p:spPr>
           <a:xfrm>
-            <a:off x="8257031" y="1645920"/>
-            <a:ext cx="1645920" cy="36576"/>
+            <a:off x="8302752" y="1600200"/>
+            <a:ext cx="2011680" cy="41148"/>
           </a:xfrm>
           <a:prstGeom prst="roundRect">
             <a:avLst/>
@@ -8368,8 +8368,8 @@
         </p:nvSpPr>
         <p:spPr>
           <a:xfrm>
-            <a:off x="8257031" y="1828800"/>
-            <a:ext cx="2971800" cy="256032"/>
+            <a:off x="8302752" y="1801368"/>
+            <a:ext cx="2880360" cy="274320"/>
           </a:xfrm>
           <a:prstGeom prst="rect">
             <a:avLst/>
@@ -8383,7 +8383,7 @@
           <a:lstStyle/>
           <a:p>
             <a:pPr>
-              <a:defRPr sz="850" b="1">
+              <a:defRPr sz="900" b="1">
                 <a:solidFill>
                   <a:srgbClr val="38BDF8"/>
                 </a:solidFill>
@@ -8404,8 +8404,8 @@
         </p:nvSpPr>
         <p:spPr>
           <a:xfrm>
-            <a:off x="8257031" y="2084832"/>
-            <a:ext cx="2971800" cy="411480"/>
+            <a:off x="8302752" y="2075688"/>
+            <a:ext cx="2880360" cy="457200"/>
           </a:xfrm>
           <a:prstGeom prst="rect">
             <a:avLst/>
@@ -8419,7 +8419,7 @@
           <a:lstStyle/>
           <a:p>
             <a:pPr>
-              <a:defRPr sz="1300" b="1">
+              <a:defRPr sz="1500" b="1">
                 <a:solidFill>
                   <a:srgbClr val="FFFFFF"/>
                 </a:solidFill>
@@ -8440,8 +8440,8 @@
         </p:nvSpPr>
         <p:spPr>
           <a:xfrm>
-            <a:off x="8257031" y="2496312"/>
-            <a:ext cx="2971800" cy="1938528"/>
+            <a:off x="8302752" y="2551176"/>
+            <a:ext cx="2880360" cy="2020824"/>
           </a:xfrm>
           <a:prstGeom prst="rect">
             <a:avLst/>
@@ -8456,11 +8456,11 @@
           <a:p>
             <a:pPr>
               <a:spcAft>
-                <a:spcPts val="500"/>
+                <a:spcPts val="800"/>
               </a:spcAft>
-              <a:defRPr sz="1000">
-                <a:solidFill>
-                  <a:srgbClr val="94A3B8"/>
+              <a:defRPr sz="1150">
+                <a:solidFill>
+                  <a:srgbClr val="A0AEC0"/>
                 </a:solidFill>
                 <a:latin typeface="Arial"/>
               </a:defRPr>
@@ -8472,11 +8472,11 @@
           <a:p>
             <a:pPr>
               <a:spcAft>
-                <a:spcPts val="500"/>
+                <a:spcPts val="800"/>
               </a:spcAft>
-              <a:defRPr sz="1000">
-                <a:solidFill>
-                  <a:srgbClr val="94A3B8"/>
+              <a:defRPr sz="1150">
+                <a:solidFill>
+                  <a:srgbClr val="A0AEC0"/>
                 </a:solidFill>
                 <a:latin typeface="Arial"/>
               </a:defRPr>
@@ -8488,11 +8488,11 @@
           <a:p>
             <a:pPr>
               <a:spcAft>
-                <a:spcPts val="500"/>
+                <a:spcPts val="800"/>
               </a:spcAft>
-              <a:defRPr sz="1000">
-                <a:solidFill>
-                  <a:srgbClr val="94A3B8"/>
+              <a:defRPr sz="1150">
+                <a:solidFill>
+                  <a:srgbClr val="A0AEC0"/>
                 </a:solidFill>
                 <a:latin typeface="Arial"/>
               </a:defRPr>
@@ -8504,11 +8504,11 @@
           <a:p>
             <a:pPr>
               <a:spcAft>
-                <a:spcPts val="500"/>
+                <a:spcPts val="800"/>
               </a:spcAft>
-              <a:defRPr sz="1000">
-                <a:solidFill>
-                  <a:srgbClr val="94A3B8"/>
+              <a:defRPr sz="1150">
+                <a:solidFill>
+                  <a:srgbClr val="A0AEC0"/>
                 </a:solidFill>
                 <a:latin typeface="Arial"/>
               </a:defRPr>
@@ -8527,8 +8527,8 @@
         </p:nvSpPr>
         <p:spPr>
           <a:xfrm>
-            <a:off x="731520" y="4800600"/>
-            <a:ext cx="10728655" cy="1417320"/>
+            <a:off x="731520" y="4892040"/>
+            <a:ext cx="10728655" cy="1463040"/>
           </a:xfrm>
           <a:prstGeom prst="roundRect">
             <a:avLst/>
@@ -8572,8 +8572,8 @@
         </p:nvSpPr>
         <p:spPr>
           <a:xfrm>
-            <a:off x="1005840" y="4937760"/>
-            <a:ext cx="10149840" cy="1097280"/>
+            <a:off x="1005840" y="5029200"/>
+            <a:ext cx="10149840" cy="1188720"/>
           </a:xfrm>
           <a:prstGeom prst="rect">
             <a:avLst/>
@@ -8590,7 +8590,7 @@
               <a:spcAft>
                 <a:spcPts val="400"/>
               </a:spcAft>
-              <a:defRPr sz="1300" b="1">
+              <a:defRPr sz="1400" b="1">
                 <a:solidFill>
                   <a:srgbClr val="00F5A0"/>
                 </a:solidFill>
@@ -8606,22 +8606,22 @@
               <a:spcAft>
                 <a:spcPts val="400"/>
               </a:spcAft>
+              <a:defRPr sz="1100">
+                <a:solidFill>
+                  <a:srgbClr val="FFFFFF"/>
+                </a:solidFill>
+                <a:latin typeface="Arial"/>
+              </a:defRPr>
+            </a:pPr>
+            <a:r>
+              <a:t>Vibe Coder, Systems Builder &amp; Applied AI/ML • Automotive &amp; Embedded Systems Engineering • Applied Mathematics</a:t>
+            </a:r>
+          </a:p>
+          <a:p>
+            <a:pPr>
               <a:defRPr sz="1000">
                 <a:solidFill>
-                  <a:srgbClr val="FFFFFF"/>
-                </a:solidFill>
-                <a:latin typeface="Arial"/>
-              </a:defRPr>
-            </a:pPr>
-            <a:r>
-              <a:t>Vibe Coder, Systems Builder &amp; Applied AI/ML • Automotive &amp; Embedded Systems Engineering • Applied Mathematics</a:t>
-            </a:r>
-          </a:p>
-          <a:p>
-            <a:pPr>
-              <a:defRPr sz="950">
-                <a:solidFill>
-                  <a:srgbClr val="94A3B8"/>
+                  <a:srgbClr val="A0AEC0"/>
                 </a:solidFill>
                 <a:latin typeface="Arial"/>
               </a:defRPr>

</xml_diff>